<commit_message>
Expand method explanations and interpretation in research deliverables
</commit_message>
<xml_diff>
--- a/deliverables/AML_presentation.pptx
+++ b/deliverables/AML_presentation.pptx
@@ -19,6 +19,17 @@
     <p:sldId id="267" r:id="rId18"/>
     <p:sldId id="268" r:id="rId19"/>
     <p:sldId id="269" r:id="rId20"/>
+    <p:sldId id="270" r:id="rId21"/>
+    <p:sldId id="271" r:id="rId22"/>
+    <p:sldId id="272" r:id="rId23"/>
+    <p:sldId id="273" r:id="rId24"/>
+    <p:sldId id="274" r:id="rId25"/>
+    <p:sldId id="275" r:id="rId26"/>
+    <p:sldId id="276" r:id="rId27"/>
+    <p:sldId id="277" r:id="rId28"/>
+    <p:sldId id="278" r:id="rId29"/>
+    <p:sldId id="279" r:id="rId30"/>
+    <p:sldId id="280" r:id="rId31"/>
   </p:sldIdLst>
   <p:sldSz cx="12191695" cy="6858000" type="screen4x3"/>
   <p:notesSz cx="6858000" cy="9144000"/>
@@ -3226,69 +3237,21 @@
               </a:defRPr>
             </a:pPr>
             <a:r>
-              <a:t>Parameter settings change the ranking</a:t>
-            </a:r>
-          </a:p>
-        </p:txBody>
-      </p:sp>
-      <p:pic>
-        <p:nvPicPr>
-          <p:cNvPr id="3" name="Picture 2" descr="HAM10000_parameters.png"/>
-          <p:cNvPicPr>
-            <a:picLocks noChangeAspect="1"/>
-          </p:cNvPicPr>
-          <p:nvPr/>
-        </p:nvPicPr>
-        <p:blipFill>
-          <a:blip r:embed="rId2"/>
-          <a:stretch>
-            <a:fillRect/>
-          </a:stretch>
-        </p:blipFill>
-        <p:spPr>
-          <a:xfrm>
-            <a:off x="502920" y="1051560"/>
-            <a:ext cx="5577840" cy="2919130"/>
-          </a:xfrm>
-          <a:prstGeom prst="rect">
-            <a:avLst/>
-          </a:prstGeom>
-        </p:spPr>
-      </p:pic>
-      <p:pic>
-        <p:nvPicPr>
-          <p:cNvPr id="4" name="Picture 3" descr="Blood_cell_parameters.png"/>
-          <p:cNvPicPr>
-            <a:picLocks noChangeAspect="1"/>
-          </p:cNvPicPr>
-          <p:nvPr/>
-        </p:nvPicPr>
-        <p:blipFill>
-          <a:blip r:embed="rId3"/>
-          <a:stretch>
-            <a:fillRect/>
-          </a:stretch>
-        </p:blipFill>
-        <p:spPr>
-          <a:xfrm>
-            <a:off x="6217920" y="1051560"/>
-            <a:ext cx="5486400" cy="2871275"/>
-          </a:xfrm>
-          <a:prstGeom prst="rect">
-            <a:avLst/>
-          </a:prstGeom>
-        </p:spPr>
-      </p:pic>
-      <p:sp>
-        <p:nvSpPr>
-          <p:cNvPr id="5" name="TextBox 4"/>
+              <a:t>Method readings: UMAP through Isomap</a:t>
+            </a:r>
+          </a:p>
+        </p:txBody>
+      </p:sp>
+      <p:sp>
+        <p:nvSpPr>
+          <p:cNvPr id="3" name="TextBox 2"/>
           <p:cNvSpPr txBox="1"/>
           <p:nvPr/>
         </p:nvSpPr>
         <p:spPr>
           <a:xfrm>
-            <a:off x="685800" y="4892040"/>
-            <a:ext cx="10881360" cy="1051560"/>
+            <a:off x="731520" y="1234440"/>
+            <a:ext cx="10789920" cy="4846320"/>
           </a:xfrm>
           <a:prstGeom prst="rect">
             <a:avLst/>
@@ -3302,7 +3265,7 @@
           <a:lstStyle/>
           <a:p>
             <a:pPr>
-              <a:defRPr sz="1700" b="0">
+              <a:defRPr sz="2100" b="0">
                 <a:solidFill>
                   <a:srgbClr val="153B50"/>
                 </a:solidFill>
@@ -3310,7 +3273,27 @@
               </a:defRPr>
             </a:pPr>
             <a:r>
-              <a:t>A second setting changes neighborhood size or perplexity. Selecting a winner on the test set would inflate the reported result.</a:t>
+              <a:t>UMAP: 0.645 HAM, 0.600 blood. The neighbor graph ranks lesions well, but costs about 2.24 CPU seconds per HAM run.</a:t>
+            </a:r>
+            <a:br/>
+            <a:br/>
+            <a:r>
+              <a:t>MDS: 0.620 HAM, 0.562 blood. Preserving global Euclidean distances gives the weakest blood-cell AUC.</a:t>
+            </a:r>
+            <a:br/>
+            <a:br/>
+            <a:r>
+              <a:t>PCoA: 0.633 HAM, 0.616 blood. Cosine distances give middle-ranking performance; a different distance changes the result.</a:t>
+            </a:r>
+            <a:br/>
+            <a:br/>
+            <a:r>
+              <a:t>Isomap: 0.649 HAM, 0.582 blood. Graph geodesics lead HAM AUC but transfer poorly to the blood-cell table.</a:t>
+            </a:r>
+            <a:br/>
+            <a:br/>
+            <a:r>
+              <a:t>The mechanisms above are interpretations of measured associations, not proven causes.</a:t>
             </a:r>
           </a:p>
         </p:txBody>
@@ -3364,14 +3347,14 @@
               </a:defRPr>
             </a:pPr>
             <a:r>
-              <a:t>Gaussian SNE optimization loss</a:t>
+              <a:t>HAM10000: accuracy and loss</a:t>
             </a:r>
           </a:p>
         </p:txBody>
       </p:sp>
       <p:pic>
         <p:nvPicPr>
-          <p:cNvPr id="3" name="Picture 2" descr="sne_objective.png"/>
+          <p:cNvPr id="3" name="Picture 2" descr="HAM10000_accuracy.png"/>
           <p:cNvPicPr>
             <a:picLocks noChangeAspect="1"/>
           </p:cNvPicPr>
@@ -3385,24 +3368,48 @@
         </p:blipFill>
         <p:spPr>
           <a:xfrm>
-            <a:off x="594360" y="1097280"/>
-            <a:ext cx="7315200" cy="2717554"/>
+            <a:off x="502920" y="1051560"/>
+            <a:ext cx="5577840" cy="2244172"/>
           </a:xfrm>
           <a:prstGeom prst="rect">
             <a:avLst/>
           </a:prstGeom>
         </p:spPr>
       </p:pic>
-      <p:sp>
-        <p:nvSpPr>
-          <p:cNvPr id="4" name="TextBox 3"/>
+      <p:pic>
+        <p:nvPicPr>
+          <p:cNvPr id="4" name="Picture 3" descr="HAM10000_loss.png"/>
+          <p:cNvPicPr>
+            <a:picLocks noChangeAspect="1"/>
+          </p:cNvPicPr>
+          <p:nvPr/>
+        </p:nvPicPr>
+        <p:blipFill>
+          <a:blip r:embed="rId3"/>
+          <a:stretch>
+            <a:fillRect/>
+          </a:stretch>
+        </p:blipFill>
+        <p:spPr>
+          <a:xfrm>
+            <a:off x="6217920" y="1051560"/>
+            <a:ext cx="5486400" cy="2207383"/>
+          </a:xfrm>
+          <a:prstGeom prst="rect">
+            <a:avLst/>
+          </a:prstGeom>
+        </p:spPr>
+      </p:pic>
+      <p:sp>
+        <p:nvSpPr>
+          <p:cNvPr id="5" name="TextBox 4"/>
           <p:cNvSpPr txBox="1"/>
           <p:nvPr/>
         </p:nvSpPr>
         <p:spPr>
           <a:xfrm>
-            <a:off x="8092440" y="1325880"/>
-            <a:ext cx="3520440" cy="4480560"/>
+            <a:off x="685800" y="4892040"/>
+            <a:ext cx="10881360" cy="1051560"/>
           </a:xfrm>
           <a:prstGeom prst="rect">
             <a:avLst/>
@@ -3416,7 +3423,7 @@
           <a:lstStyle/>
           <a:p>
             <a:pPr>
-              <a:defRPr sz="1800" b="0">
+              <a:defRPr sz="1700" b="0">
                 <a:solidFill>
                   <a:srgbClr val="153B50"/>
                 </a:solidFill>
@@ -3424,7 +3431,7 @@
               </a:defRPr>
             </a:pPr>
             <a:r>
-              <a:t>The plotted KL objective tracks Gaussian SNE fitting. Native PCA, t-SNE, and UMAP objectives have different meanings. The earlier classifier log-loss charts are comparable across methods.</a:t>
+              <a:t>Highest mean AUC: Isomap, 0.649. The two charts show why accuracy and probability loss should be read together.</a:t>
             </a:r>
           </a:p>
         </p:txBody>
@@ -3478,14 +3485,14 @@
               </a:defRPr>
             </a:pPr>
             <a:r>
-              <a:t>FROC AUC is not available</a:t>
+              <a:t>HAM10000: ROC and confusion matrices</a:t>
             </a:r>
           </a:p>
         </p:txBody>
       </p:sp>
       <p:pic>
         <p:nvPicPr>
-          <p:cNvPr id="3" name="Picture 2" descr="froc_applicability.png"/>
+          <p:cNvPr id="3" name="Picture 2" descr="HAM10000_roc.png"/>
           <p:cNvPicPr>
             <a:picLocks noChangeAspect="1"/>
           </p:cNvPicPr>
@@ -3499,50 +3506,38 @@
         </p:blipFill>
         <p:spPr>
           <a:xfrm>
-            <a:off x="594360" y="1097280"/>
-            <a:ext cx="7315200" cy="2817280"/>
+            <a:off x="502920" y="1051560"/>
+            <a:ext cx="5577840" cy="4395580"/>
           </a:xfrm>
           <a:prstGeom prst="rect">
             <a:avLst/>
           </a:prstGeom>
         </p:spPr>
       </p:pic>
-      <p:sp>
-        <p:nvSpPr>
-          <p:cNvPr id="4" name="TextBox 3"/>
-          <p:cNvSpPr txBox="1"/>
-          <p:nvPr/>
-        </p:nvSpPr>
-        <p:spPr>
-          <a:xfrm>
-            <a:off x="8092440" y="1325880"/>
-            <a:ext cx="3520440" cy="4480560"/>
-          </a:xfrm>
-          <a:prstGeom prst="rect">
-            <a:avLst/>
-          </a:prstGeom>
-          <a:noFill/>
-        </p:spPr>
-        <p:txBody>
-          <a:bodyPr wrap="square">
-            <a:spAutoFit/>
-          </a:bodyPr>
-          <a:lstStyle/>
-          <a:p>
-            <a:pPr>
-              <a:defRPr sz="1800" b="0">
-                <a:solidFill>
-                  <a:srgbClr val="153B50"/>
-                </a:solidFill>
-                <a:latin typeface="Aptos"/>
-              </a:defRPr>
-            </a:pPr>
-            <a:r>
-              <a:t>ROC AUC is reported. A valid FROC needs scored candidate lesion locations and false positives per image. These tables have one label and one score per record.</a:t>
-            </a:r>
-          </a:p>
-        </p:txBody>
-      </p:sp>
+      <p:pic>
+        <p:nvPicPr>
+          <p:cNvPr id="4" name="Picture 3" descr="HAM10000_confusion.png"/>
+          <p:cNvPicPr>
+            <a:picLocks noChangeAspect="1"/>
+          </p:cNvPicPr>
+          <p:nvPr/>
+        </p:nvPicPr>
+        <p:blipFill>
+          <a:blip r:embed="rId3"/>
+          <a:stretch>
+            <a:fillRect/>
+          </a:stretch>
+        </p:blipFill>
+        <p:spPr>
+          <a:xfrm>
+            <a:off x="6217920" y="1051560"/>
+            <a:ext cx="5486400" cy="5481010"/>
+          </a:xfrm>
+          <a:prstGeom prst="rect">
+            <a:avLst/>
+          </a:prstGeom>
+        </p:spPr>
+      </p:pic>
     </p:spTree>
   </p:cSld>
   <p:clrMapOvr>
@@ -3592,7 +3587,7 @@
               </a:defRPr>
             </a:pPr>
             <a:r>
-              <a:t>Statistical tests are exploratory</a:t>
+              <a:t>HAM10000: better ranking, weak positive precision</a:t>
             </a:r>
           </a:p>
         </p:txBody>
@@ -3628,12 +3623,17 @@
               </a:defRPr>
             </a:pPr>
             <a:r>
-              <a:t>Repeated-measures ANOVA of AUC: F(8,40)=0.673, p=0.712. Descriptive MANOVA method term: Wilks' lambda=0.840, p=0.945.</a:t>
-            </a:r>
-            <a:br/>
-            <a:br/>
-            <a:r>
-              <a:t>Paired t, Wilcoxon, and McNemar z comparisons are in the repository. Three overlapping splits have low power. MANOVA's independence assumption is violated. Read all p values as diagnostics.</a:t>
+              <a:t>Isomap leads mean ROC AUC at 0.649, versus 0.602 for PCA. A neighbor graph may retain class-related structure that the largest-variance PCA axes miss. The experiment does not establish that mechanism.</a:t>
+            </a:r>
+            <a:br/>
+            <a:br/>
+            <a:r>
+              <a:t>PCA has slightly higher accuracy, 0.609 versus 0.590. AUC measures ranking across thresholds, while accuracy uses the prespecified 0.5 threshold.</a:t>
+            </a:r>
+            <a:br/>
+            <a:br/>
+            <a:r>
+              <a:t>Isomap precision is 0.134: most positive calls are false positives. The 8 × 8 pixels and low melanoma prevalence limit clinical meaning.</a:t>
             </a:r>
           </a:p>
         </p:txBody>
@@ -3687,21 +3687,69 @@
               </a:defRPr>
             </a:pPr>
             <a:r>
-              <a:t>Interpretation and next steps</a:t>
-            </a:r>
-          </a:p>
-        </p:txBody>
-      </p:sp>
-      <p:sp>
-        <p:nvSpPr>
-          <p:cNvPr id="3" name="TextBox 2"/>
+              <a:t>Blood cell: accuracy and loss</a:t>
+            </a:r>
+          </a:p>
+        </p:txBody>
+      </p:sp>
+      <p:pic>
+        <p:nvPicPr>
+          <p:cNvPr id="3" name="Picture 2" descr="Blood_cell_accuracy.png"/>
+          <p:cNvPicPr>
+            <a:picLocks noChangeAspect="1"/>
+          </p:cNvPicPr>
+          <p:nvPr/>
+        </p:nvPicPr>
+        <p:blipFill>
+          <a:blip r:embed="rId2"/>
+          <a:stretch>
+            <a:fillRect/>
+          </a:stretch>
+        </p:blipFill>
+        <p:spPr>
+          <a:xfrm>
+            <a:off x="502920" y="1051560"/>
+            <a:ext cx="5577840" cy="2244172"/>
+          </a:xfrm>
+          <a:prstGeom prst="rect">
+            <a:avLst/>
+          </a:prstGeom>
+        </p:spPr>
+      </p:pic>
+      <p:pic>
+        <p:nvPicPr>
+          <p:cNvPr id="4" name="Picture 3" descr="Blood_cell_loss.png"/>
+          <p:cNvPicPr>
+            <a:picLocks noChangeAspect="1"/>
+          </p:cNvPicPr>
+          <p:nvPr/>
+        </p:nvPicPr>
+        <p:blipFill>
+          <a:blip r:embed="rId3"/>
+          <a:stretch>
+            <a:fillRect/>
+          </a:stretch>
+        </p:blipFill>
+        <p:spPr>
+          <a:xfrm>
+            <a:off x="6217920" y="1051560"/>
+            <a:ext cx="5486400" cy="2207383"/>
+          </a:xfrm>
+          <a:prstGeom prst="rect">
+            <a:avLst/>
+          </a:prstGeom>
+        </p:spPr>
+      </p:pic>
+      <p:sp>
+        <p:nvSpPr>
+          <p:cNvPr id="5" name="TextBox 4"/>
           <p:cNvSpPr txBox="1"/>
           <p:nvPr/>
         </p:nvSpPr>
         <p:spPr>
           <a:xfrm>
-            <a:off x="731520" y="1234440"/>
-            <a:ext cx="10789920" cy="4846320"/>
+            <a:off x="685800" y="4892040"/>
+            <a:ext cx="10881360" cy="1051560"/>
           </a:xfrm>
           <a:prstGeom prst="rect">
             <a:avLst/>
@@ -3715,7 +3763,7 @@
           <a:lstStyle/>
           <a:p>
             <a:pPr>
-              <a:defRPr sz="2100" b="0">
+              <a:defRPr sz="1700" b="0">
                 <a:solidFill>
                   <a:srgbClr val="153B50"/>
                 </a:solidFill>
@@ -3723,26 +3771,39 @@
               </a:defRPr>
             </a:pPr>
             <a:r>
-              <a:t>Performance changes with split and parameter choice. The 8 × 8 lesion images limit clinical meaning. The blood-cell table lacks patient-level validation.</a:t>
-            </a:r>
-            <a:br/>
-            <a:br/>
-            <a:r>
-              <a:t>For a journal study: use original or validated features, external cohorts, nested tuning, uncertainty intervals, and lesion locations if FROC is required.</a:t>
-            </a:r>
-          </a:p>
-        </p:txBody>
-      </p:sp>
-      <p:sp>
-        <p:nvSpPr>
-          <p:cNvPr id="4" name="TextBox 3"/>
+              <a:t>Highest mean AUC: PCA, 0.630. The two charts show why accuracy and probability loss should be read together.</a:t>
+            </a:r>
+          </a:p>
+        </p:txBody>
+      </p:sp>
+    </p:spTree>
+  </p:cSld>
+  <p:clrMapOvr>
+    <a:masterClrMapping/>
+  </p:clrMapOvr>
+</p:sld>
+</file>
+
+<file path=ppt/slides/slide15.xml><?xml version="1.0" encoding="utf-8"?>
+<p:sld xmlns:a="http://schemas.openxmlformats.org/drawingml/2006/main" xmlns:p="http://schemas.openxmlformats.org/presentationml/2006/main" xmlns:r="http://schemas.openxmlformats.org/officeDocument/2006/relationships">
+  <p:cSld>
+    <p:spTree>
+      <p:nvGrpSpPr>
+        <p:cNvPr id="1" name=""/>
+        <p:cNvGrpSpPr/>
+        <p:nvPr/>
+      </p:nvGrpSpPr>
+      <p:grpSpPr/>
+      <p:sp>
+        <p:nvSpPr>
+          <p:cNvPr id="2" name="TextBox 1"/>
           <p:cNvSpPr txBox="1"/>
           <p:nvPr/>
         </p:nvSpPr>
         <p:spPr>
           <a:xfrm>
-            <a:off x="594360" y="6446520"/>
-            <a:ext cx="10972800" cy="274320"/>
+            <a:off x="502920" y="228600"/>
+            <a:ext cx="10972800" cy="640080"/>
           </a:xfrm>
           <a:prstGeom prst="rect">
             <a:avLst/>
@@ -3756,15 +3817,539 @@
           <a:lstStyle/>
           <a:p>
             <a:pPr>
-              <a:defRPr sz="1000" b="0">
-                <a:solidFill>
-                  <a:srgbClr val="5C6770"/>
+              <a:defRPr sz="2900" b="1">
+                <a:solidFill>
+                  <a:srgbClr val="153B50"/>
                 </a:solidFill>
                 <a:latin typeface="Aptos"/>
               </a:defRPr>
             </a:pPr>
             <a:r>
-              <a:t>Sources and exact numbers: AML_research_report.docx and results/primary_summary.csv</a:t>
+              <a:t>Blood cell: ROC and confusion matrices</a:t>
+            </a:r>
+          </a:p>
+        </p:txBody>
+      </p:sp>
+      <p:pic>
+        <p:nvPicPr>
+          <p:cNvPr id="3" name="Picture 2" descr="Blood_cell_roc.png"/>
+          <p:cNvPicPr>
+            <a:picLocks noChangeAspect="1"/>
+          </p:cNvPicPr>
+          <p:nvPr/>
+        </p:nvPicPr>
+        <p:blipFill>
+          <a:blip r:embed="rId2"/>
+          <a:stretch>
+            <a:fillRect/>
+          </a:stretch>
+        </p:blipFill>
+        <p:spPr>
+          <a:xfrm>
+            <a:off x="502920" y="1051560"/>
+            <a:ext cx="5577840" cy="4395580"/>
+          </a:xfrm>
+          <a:prstGeom prst="rect">
+            <a:avLst/>
+          </a:prstGeom>
+        </p:spPr>
+      </p:pic>
+      <p:pic>
+        <p:nvPicPr>
+          <p:cNvPr id="4" name="Picture 3" descr="Blood_cell_confusion.png"/>
+          <p:cNvPicPr>
+            <a:picLocks noChangeAspect="1"/>
+          </p:cNvPicPr>
+          <p:nvPr/>
+        </p:nvPicPr>
+        <p:blipFill>
+          <a:blip r:embed="rId3"/>
+          <a:stretch>
+            <a:fillRect/>
+          </a:stretch>
+        </p:blipFill>
+        <p:spPr>
+          <a:xfrm>
+            <a:off x="6217920" y="1051560"/>
+            <a:ext cx="5486400" cy="5481010"/>
+          </a:xfrm>
+          <a:prstGeom prst="rect">
+            <a:avLst/>
+          </a:prstGeom>
+        </p:spPr>
+      </p:pic>
+    </p:spTree>
+  </p:cSld>
+  <p:clrMapOvr>
+    <a:masterClrMapping/>
+  </p:clrMapOvr>
+</p:sld>
+</file>
+
+<file path=ppt/slides/slide16.xml><?xml version="1.0" encoding="utf-8"?>
+<p:sld xmlns:a="http://schemas.openxmlformats.org/drawingml/2006/main" xmlns:p="http://schemas.openxmlformats.org/presentationml/2006/main" xmlns:r="http://schemas.openxmlformats.org/officeDocument/2006/relationships">
+  <p:cSld>
+    <p:spTree>
+      <p:nvGrpSpPr>
+        <p:cNvPr id="1" name=""/>
+        <p:cNvGrpSpPr/>
+        <p:nvPr/>
+      </p:nvGrpSpPr>
+      <p:grpSpPr/>
+      <p:sp>
+        <p:nvSpPr>
+          <p:cNvPr id="2" name="TextBox 1"/>
+          <p:cNvSpPr txBox="1"/>
+          <p:nvPr/>
+        </p:nvSpPr>
+        <p:spPr>
+          <a:xfrm>
+            <a:off x="502920" y="228600"/>
+            <a:ext cx="10972800" cy="640080"/>
+          </a:xfrm>
+          <a:prstGeom prst="rect">
+            <a:avLst/>
+          </a:prstGeom>
+          <a:noFill/>
+        </p:spPr>
+        <p:txBody>
+          <a:bodyPr wrap="square">
+            <a:spAutoFit/>
+          </a:bodyPr>
+          <a:lstStyle/>
+          <a:p>
+            <a:pPr>
+              <a:defRPr sz="2900" b="1">
+                <a:solidFill>
+                  <a:srgbClr val="153B50"/>
+                </a:solidFill>
+                <a:latin typeface="Aptos"/>
+              </a:defRPr>
+            </a:pPr>
+            <a:r>
+              <a:t>Blood cells: fast PCA wins on ranking</a:t>
+            </a:r>
+          </a:p>
+        </p:txBody>
+      </p:sp>
+      <p:sp>
+        <p:nvSpPr>
+          <p:cNvPr id="3" name="TextBox 2"/>
+          <p:cNvSpPr txBox="1"/>
+          <p:nvPr/>
+        </p:nvSpPr>
+        <p:spPr>
+          <a:xfrm>
+            <a:off x="731520" y="1234440"/>
+            <a:ext cx="10789920" cy="4846320"/>
+          </a:xfrm>
+          <a:prstGeom prst="rect">
+            <a:avLst/>
+          </a:prstGeom>
+          <a:noFill/>
+        </p:spPr>
+        <p:txBody>
+          <a:bodyPr wrap="square">
+            <a:spAutoFit/>
+          </a:bodyPr>
+          <a:lstStyle/>
+          <a:p>
+            <a:pPr>
+              <a:defRPr sz="2100" b="0">
+                <a:solidFill>
+                  <a:srgbClr val="153B50"/>
+                </a:solidFill>
+                <a:latin typeface="Aptos"/>
+              </a:defRPr>
+            </a:pPr>
+            <a:r>
+              <a:t>PCA leads mean ROC AUC at 0.630 and takes about 0.02 CPU seconds. Broad linear variation may capture useful signal in the 22 selected features.</a:t>
+            </a:r>
+            <a:br/>
+            <a:br/>
+            <a:r>
+              <a:t>SNE reaches 0.614 accuracy but only 0.581 AUC. Its threshold decisions look better than its overall ranking; accuracy alone would give a misleading winner.</a:t>
+            </a:r>
+            <a:br/>
+            <a:br/>
+            <a:r>
+              <a:t>MDS has 0.562 AUC and takes about 1.06 CPU seconds. Keeping global distances in two dimensions did not retain much class signal here. Patient-level generalization remains untested.</a:t>
+            </a:r>
+          </a:p>
+        </p:txBody>
+      </p:sp>
+    </p:spTree>
+  </p:cSld>
+  <p:clrMapOvr>
+    <a:masterClrMapping/>
+  </p:clrMapOvr>
+</p:sld>
+</file>
+
+<file path=ppt/slides/slide17.xml><?xml version="1.0" encoding="utf-8"?>
+<p:sld xmlns:a="http://schemas.openxmlformats.org/drawingml/2006/main" xmlns:p="http://schemas.openxmlformats.org/presentationml/2006/main" xmlns:r="http://schemas.openxmlformats.org/officeDocument/2006/relationships">
+  <p:cSld>
+    <p:spTree>
+      <p:nvGrpSpPr>
+        <p:cNvPr id="1" name=""/>
+        <p:cNvGrpSpPr/>
+        <p:nvPr/>
+      </p:nvGrpSpPr>
+      <p:grpSpPr/>
+      <p:sp>
+        <p:nvSpPr>
+          <p:cNvPr id="2" name="TextBox 1"/>
+          <p:cNvSpPr txBox="1"/>
+          <p:nvPr/>
+        </p:nvSpPr>
+        <p:spPr>
+          <a:xfrm>
+            <a:off x="502920" y="228600"/>
+            <a:ext cx="10972800" cy="640080"/>
+          </a:xfrm>
+          <a:prstGeom prst="rect">
+            <a:avLst/>
+          </a:prstGeom>
+          <a:noFill/>
+        </p:spPr>
+        <p:txBody>
+          <a:bodyPr wrap="square">
+            <a:spAutoFit/>
+          </a:bodyPr>
+          <a:lstStyle/>
+          <a:p>
+            <a:pPr>
+              <a:defRPr sz="2900" b="1">
+                <a:solidFill>
+                  <a:srgbClr val="153B50"/>
+                </a:solidFill>
+                <a:latin typeface="Aptos"/>
+              </a:defRPr>
+            </a:pPr>
+            <a:r>
+              <a:t>CPU time has a steep method cost</a:t>
+            </a:r>
+          </a:p>
+        </p:txBody>
+      </p:sp>
+      <p:pic>
+        <p:nvPicPr>
+          <p:cNvPr id="3" name="Picture 2" descr="HAM10000_cpu.png"/>
+          <p:cNvPicPr>
+            <a:picLocks noChangeAspect="1"/>
+          </p:cNvPicPr>
+          <p:nvPr/>
+        </p:nvPicPr>
+        <p:blipFill>
+          <a:blip r:embed="rId2"/>
+          <a:stretch>
+            <a:fillRect/>
+          </a:stretch>
+        </p:blipFill>
+        <p:spPr>
+          <a:xfrm>
+            <a:off x="502920" y="1051560"/>
+            <a:ext cx="5577840" cy="2244172"/>
+          </a:xfrm>
+          <a:prstGeom prst="rect">
+            <a:avLst/>
+          </a:prstGeom>
+        </p:spPr>
+      </p:pic>
+      <p:pic>
+        <p:nvPicPr>
+          <p:cNvPr id="4" name="Picture 3" descr="Blood_cell_cpu.png"/>
+          <p:cNvPicPr>
+            <a:picLocks noChangeAspect="1"/>
+          </p:cNvPicPr>
+          <p:nvPr/>
+        </p:nvPicPr>
+        <p:blipFill>
+          <a:blip r:embed="rId3"/>
+          <a:stretch>
+            <a:fillRect/>
+          </a:stretch>
+        </p:blipFill>
+        <p:spPr>
+          <a:xfrm>
+            <a:off x="6217920" y="1051560"/>
+            <a:ext cx="5486400" cy="2207383"/>
+          </a:xfrm>
+          <a:prstGeom prst="rect">
+            <a:avLst/>
+          </a:prstGeom>
+        </p:spPr>
+      </p:pic>
+      <p:sp>
+        <p:nvSpPr>
+          <p:cNvPr id="5" name="TextBox 4"/>
+          <p:cNvSpPr txBox="1"/>
+          <p:nvPr/>
+        </p:nvSpPr>
+        <p:spPr>
+          <a:xfrm>
+            <a:off x="685800" y="4892040"/>
+            <a:ext cx="10881360" cy="1051560"/>
+          </a:xfrm>
+          <a:prstGeom prst="rect">
+            <a:avLst/>
+          </a:prstGeom>
+          <a:noFill/>
+        </p:spPr>
+        <p:txBody>
+          <a:bodyPr wrap="square">
+            <a:spAutoFit/>
+          </a:bodyPr>
+          <a:lstStyle/>
+          <a:p>
+            <a:pPr>
+              <a:defRPr sz="1700" b="0">
+                <a:solidFill>
+                  <a:srgbClr val="153B50"/>
+                </a:solidFill>
+                <a:latin typeface="Aptos"/>
+              </a:defRPr>
+            </a:pPr>
+            <a:r>
+              <a:t>PCA and kernel PCA are fastest in this sample-size range. UMAP, SNE, and t-SNE require substantially more CPU time. UMAP's first compilation is measured separately.</a:t>
+            </a:r>
+          </a:p>
+        </p:txBody>
+      </p:sp>
+    </p:spTree>
+  </p:cSld>
+  <p:clrMapOvr>
+    <a:masterClrMapping/>
+  </p:clrMapOvr>
+</p:sld>
+</file>
+
+<file path=ppt/slides/slide18.xml><?xml version="1.0" encoding="utf-8"?>
+<p:sld xmlns:a="http://schemas.openxmlformats.org/drawingml/2006/main" xmlns:p="http://schemas.openxmlformats.org/presentationml/2006/main" xmlns:r="http://schemas.openxmlformats.org/officeDocument/2006/relationships">
+  <p:cSld>
+    <p:spTree>
+      <p:nvGrpSpPr>
+        <p:cNvPr id="1" name=""/>
+        <p:cNvGrpSpPr/>
+        <p:nvPr/>
+      </p:nvGrpSpPr>
+      <p:grpSpPr/>
+      <p:sp>
+        <p:nvSpPr>
+          <p:cNvPr id="2" name="TextBox 1"/>
+          <p:cNvSpPr txBox="1"/>
+          <p:nvPr/>
+        </p:nvSpPr>
+        <p:spPr>
+          <a:xfrm>
+            <a:off x="502920" y="228600"/>
+            <a:ext cx="10972800" cy="640080"/>
+          </a:xfrm>
+          <a:prstGeom prst="rect">
+            <a:avLst/>
+          </a:prstGeom>
+          <a:noFill/>
+        </p:spPr>
+        <p:txBody>
+          <a:bodyPr wrap="square">
+            <a:spAutoFit/>
+          </a:bodyPr>
+          <a:lstStyle/>
+          <a:p>
+            <a:pPr>
+              <a:defRPr sz="2900" b="1">
+                <a:solidFill>
+                  <a:srgbClr val="153B50"/>
+                </a:solidFill>
+                <a:latin typeface="Aptos"/>
+              </a:defRPr>
+            </a:pPr>
+            <a:r>
+              <a:t>CPU cost changes the practical choice</a:t>
+            </a:r>
+          </a:p>
+        </p:txBody>
+      </p:sp>
+      <p:sp>
+        <p:nvSpPr>
+          <p:cNvPr id="3" name="TextBox 2"/>
+          <p:cNvSpPr txBox="1"/>
+          <p:nvPr/>
+        </p:nvSpPr>
+        <p:spPr>
+          <a:xfrm>
+            <a:off x="731520" y="1234440"/>
+            <a:ext cx="10789920" cy="4846320"/>
+          </a:xfrm>
+          <a:prstGeom prst="rect">
+            <a:avLst/>
+          </a:prstGeom>
+          <a:noFill/>
+        </p:spPr>
+        <p:txBody>
+          <a:bodyPr wrap="square">
+            <a:spAutoFit/>
+          </a:bodyPr>
+          <a:lstStyle/>
+          <a:p>
+            <a:pPr>
+              <a:defRPr sz="2100" b="0">
+                <a:solidFill>
+                  <a:srgbClr val="153B50"/>
+                </a:solidFill>
+                <a:latin typeface="Aptos"/>
+              </a:defRPr>
+            </a:pPr>
+            <a:r>
+              <a:t>On blood cells, PCA needs about 0.02 CPU seconds and SNE about 6.10 seconds per run. SNE does not gain AUC in exchange for that extra compute (0.581 versus 0.630).</a:t>
+            </a:r>
+            <a:br/>
+            <a:br/>
+            <a:r>
+              <a:t>On HAM10000, Isomap leads AUC at about 0.10 CPU seconds; UMAP is close in AUC (0.645 versus 0.649) but takes about 2.24 seconds.</a:t>
+            </a:r>
+            <a:br/>
+            <a:br/>
+            <a:r>
+              <a:t>These are process CPU times for 750 training and 300 test records. UMAP's one-time compilation warmup is excluded and recorded separately; scaling can change the order.</a:t>
+            </a:r>
+          </a:p>
+        </p:txBody>
+      </p:sp>
+    </p:spTree>
+  </p:cSld>
+  <p:clrMapOvr>
+    <a:masterClrMapping/>
+  </p:clrMapOvr>
+</p:sld>
+</file>
+
+<file path=ppt/slides/slide19.xml><?xml version="1.0" encoding="utf-8"?>
+<p:sld xmlns:a="http://schemas.openxmlformats.org/drawingml/2006/main" xmlns:p="http://schemas.openxmlformats.org/presentationml/2006/main" xmlns:r="http://schemas.openxmlformats.org/officeDocument/2006/relationships">
+  <p:cSld>
+    <p:spTree>
+      <p:nvGrpSpPr>
+        <p:cNvPr id="1" name=""/>
+        <p:cNvGrpSpPr/>
+        <p:nvPr/>
+      </p:nvGrpSpPr>
+      <p:grpSpPr/>
+      <p:sp>
+        <p:nvSpPr>
+          <p:cNvPr id="2" name="TextBox 1"/>
+          <p:cNvSpPr txBox="1"/>
+          <p:nvPr/>
+        </p:nvSpPr>
+        <p:spPr>
+          <a:xfrm>
+            <a:off x="502920" y="228600"/>
+            <a:ext cx="10972800" cy="640080"/>
+          </a:xfrm>
+          <a:prstGeom prst="rect">
+            <a:avLst/>
+          </a:prstGeom>
+          <a:noFill/>
+        </p:spPr>
+        <p:txBody>
+          <a:bodyPr wrap="square">
+            <a:spAutoFit/>
+          </a:bodyPr>
+          <a:lstStyle/>
+          <a:p>
+            <a:pPr>
+              <a:defRPr sz="2900" b="1">
+                <a:solidFill>
+                  <a:srgbClr val="153B50"/>
+                </a:solidFill>
+                <a:latin typeface="Aptos"/>
+              </a:defRPr>
+            </a:pPr>
+            <a:r>
+              <a:t>Parameter settings change the ranking</a:t>
+            </a:r>
+          </a:p>
+        </p:txBody>
+      </p:sp>
+      <p:pic>
+        <p:nvPicPr>
+          <p:cNvPr id="3" name="Picture 2" descr="HAM10000_parameters.png"/>
+          <p:cNvPicPr>
+            <a:picLocks noChangeAspect="1"/>
+          </p:cNvPicPr>
+          <p:nvPr/>
+        </p:nvPicPr>
+        <p:blipFill>
+          <a:blip r:embed="rId2"/>
+          <a:stretch>
+            <a:fillRect/>
+          </a:stretch>
+        </p:blipFill>
+        <p:spPr>
+          <a:xfrm>
+            <a:off x="502920" y="1051560"/>
+            <a:ext cx="5577840" cy="2919130"/>
+          </a:xfrm>
+          <a:prstGeom prst="rect">
+            <a:avLst/>
+          </a:prstGeom>
+        </p:spPr>
+      </p:pic>
+      <p:pic>
+        <p:nvPicPr>
+          <p:cNvPr id="4" name="Picture 3" descr="Blood_cell_parameters.png"/>
+          <p:cNvPicPr>
+            <a:picLocks noChangeAspect="1"/>
+          </p:cNvPicPr>
+          <p:nvPr/>
+        </p:nvPicPr>
+        <p:blipFill>
+          <a:blip r:embed="rId3"/>
+          <a:stretch>
+            <a:fillRect/>
+          </a:stretch>
+        </p:blipFill>
+        <p:spPr>
+          <a:xfrm>
+            <a:off x="6217920" y="1051560"/>
+            <a:ext cx="5486400" cy="2871275"/>
+          </a:xfrm>
+          <a:prstGeom prst="rect">
+            <a:avLst/>
+          </a:prstGeom>
+        </p:spPr>
+      </p:pic>
+      <p:sp>
+        <p:nvSpPr>
+          <p:cNvPr id="5" name="TextBox 4"/>
+          <p:cNvSpPr txBox="1"/>
+          <p:nvPr/>
+        </p:nvSpPr>
+        <p:spPr>
+          <a:xfrm>
+            <a:off x="685800" y="4892040"/>
+            <a:ext cx="10881360" cy="1051560"/>
+          </a:xfrm>
+          <a:prstGeom prst="rect">
+            <a:avLst/>
+          </a:prstGeom>
+          <a:noFill/>
+        </p:spPr>
+        <p:txBody>
+          <a:bodyPr wrap="square">
+            <a:spAutoFit/>
+          </a:bodyPr>
+          <a:lstStyle/>
+          <a:p>
+            <a:pPr>
+              <a:defRPr sz="1700" b="0">
+                <a:solidFill>
+                  <a:srgbClr val="153B50"/>
+                </a:solidFill>
+                <a:latin typeface="Aptos"/>
+              </a:defRPr>
+            </a:pPr>
+            <a:r>
+              <a:t>A second setting changes neighborhood size or perplexity. Selecting a winner on the test set would inflate the reported result.</a:t>
             </a:r>
           </a:p>
         </p:txBody>
@@ -3877,6 +4462,660 @@
 </p:sld>
 </file>
 
+<file path=ppt/slides/slide20.xml><?xml version="1.0" encoding="utf-8"?>
+<p:sld xmlns:a="http://schemas.openxmlformats.org/drawingml/2006/main" xmlns:p="http://schemas.openxmlformats.org/presentationml/2006/main" xmlns:r="http://schemas.openxmlformats.org/officeDocument/2006/relationships">
+  <p:cSld>
+    <p:spTree>
+      <p:nvGrpSpPr>
+        <p:cNvPr id="1" name=""/>
+        <p:cNvGrpSpPr/>
+        <p:nvPr/>
+      </p:nvGrpSpPr>
+      <p:grpSpPr/>
+      <p:sp>
+        <p:nvSpPr>
+          <p:cNvPr id="2" name="TextBox 1"/>
+          <p:cNvSpPr txBox="1"/>
+          <p:nvPr/>
+        </p:nvSpPr>
+        <p:spPr>
+          <a:xfrm>
+            <a:off x="502920" y="228600"/>
+            <a:ext cx="10972800" cy="640080"/>
+          </a:xfrm>
+          <a:prstGeom prst="rect">
+            <a:avLst/>
+          </a:prstGeom>
+          <a:noFill/>
+        </p:spPr>
+        <p:txBody>
+          <a:bodyPr wrap="square">
+            <a:spAutoFit/>
+          </a:bodyPr>
+          <a:lstStyle/>
+          <a:p>
+            <a:pPr>
+              <a:defRPr sz="2900" b="1">
+                <a:solidFill>
+                  <a:srgbClr val="153B50"/>
+                </a:solidFill>
+                <a:latin typeface="Aptos"/>
+              </a:defRPr>
+            </a:pPr>
+            <a:r>
+              <a:t>What the parameter comparison can and cannot say</a:t>
+            </a:r>
+          </a:p>
+        </p:txBody>
+      </p:sp>
+      <p:sp>
+        <p:nvSpPr>
+          <p:cNvPr id="3" name="TextBox 2"/>
+          <p:cNvSpPr txBox="1"/>
+          <p:nvPr/>
+        </p:nvSpPr>
+        <p:spPr>
+          <a:xfrm>
+            <a:off x="731520" y="1234440"/>
+            <a:ext cx="10789920" cy="4846320"/>
+          </a:xfrm>
+          <a:prstGeom prst="rect">
+            <a:avLst/>
+          </a:prstGeom>
+          <a:noFill/>
+        </p:spPr>
+        <p:txBody>
+          <a:bodyPr wrap="square">
+            <a:spAutoFit/>
+          </a:bodyPr>
+          <a:lstStyle/>
+          <a:p>
+            <a:pPr>
+              <a:defRPr sz="2100" b="0">
+                <a:solidFill>
+                  <a:srgbClr val="153B50"/>
+                </a:solidFill>
+                <a:latin typeface="Aptos"/>
+              </a:defRPr>
+            </a:pPr>
+            <a:r>
+              <a:t>Setting A was declared primary before reading test results. Setting B checks whether whitening, kernel scale, perplexity, neighbor count, MDS iterations, or PCoA distance changes the result.</a:t>
+            </a:r>
+            <a:br/>
+            <a:br/>
+            <a:r>
+              <a:t>Large A-to-B shifts show tuning sensitivity, especially for methods that define neighborhoods. They do not justify choosing the better test-set setting after the fact.</a:t>
+            </a:r>
+            <a:br/>
+            <a:br/>
+            <a:r>
+              <a:t>A stronger study would tune parameters inside each training fold and then evaluate once on an untouched outer test fold.</a:t>
+            </a:r>
+          </a:p>
+        </p:txBody>
+      </p:sp>
+    </p:spTree>
+  </p:cSld>
+  <p:clrMapOvr>
+    <a:masterClrMapping/>
+  </p:clrMapOvr>
+</p:sld>
+</file>
+
+<file path=ppt/slides/slide21.xml><?xml version="1.0" encoding="utf-8"?>
+<p:sld xmlns:a="http://schemas.openxmlformats.org/drawingml/2006/main" xmlns:p="http://schemas.openxmlformats.org/presentationml/2006/main" xmlns:r="http://schemas.openxmlformats.org/officeDocument/2006/relationships">
+  <p:cSld>
+    <p:spTree>
+      <p:nvGrpSpPr>
+        <p:cNvPr id="1" name=""/>
+        <p:cNvGrpSpPr/>
+        <p:nvPr/>
+      </p:nvGrpSpPr>
+      <p:grpSpPr/>
+      <p:sp>
+        <p:nvSpPr>
+          <p:cNvPr id="2" name="TextBox 1"/>
+          <p:cNvSpPr txBox="1"/>
+          <p:nvPr/>
+        </p:nvSpPr>
+        <p:spPr>
+          <a:xfrm>
+            <a:off x="502920" y="228600"/>
+            <a:ext cx="10972800" cy="640080"/>
+          </a:xfrm>
+          <a:prstGeom prst="rect">
+            <a:avLst/>
+          </a:prstGeom>
+          <a:noFill/>
+        </p:spPr>
+        <p:txBody>
+          <a:bodyPr wrap="square">
+            <a:spAutoFit/>
+          </a:bodyPr>
+          <a:lstStyle/>
+          <a:p>
+            <a:pPr>
+              <a:defRPr sz="2900" b="1">
+                <a:solidFill>
+                  <a:srgbClr val="153B50"/>
+                </a:solidFill>
+                <a:latin typeface="Aptos"/>
+              </a:defRPr>
+            </a:pPr>
+            <a:r>
+              <a:t>Gaussian SNE optimization loss</a:t>
+            </a:r>
+          </a:p>
+        </p:txBody>
+      </p:sp>
+      <p:pic>
+        <p:nvPicPr>
+          <p:cNvPr id="3" name="Picture 2" descr="sne_objective.png"/>
+          <p:cNvPicPr>
+            <a:picLocks noChangeAspect="1"/>
+          </p:cNvPicPr>
+          <p:nvPr/>
+        </p:nvPicPr>
+        <p:blipFill>
+          <a:blip r:embed="rId2"/>
+          <a:stretch>
+            <a:fillRect/>
+          </a:stretch>
+        </p:blipFill>
+        <p:spPr>
+          <a:xfrm>
+            <a:off x="594360" y="1097280"/>
+            <a:ext cx="7315200" cy="2717554"/>
+          </a:xfrm>
+          <a:prstGeom prst="rect">
+            <a:avLst/>
+          </a:prstGeom>
+        </p:spPr>
+      </p:pic>
+      <p:sp>
+        <p:nvSpPr>
+          <p:cNvPr id="4" name="TextBox 3"/>
+          <p:cNvSpPr txBox="1"/>
+          <p:nvPr/>
+        </p:nvSpPr>
+        <p:spPr>
+          <a:xfrm>
+            <a:off x="8092440" y="1325880"/>
+            <a:ext cx="3520440" cy="4480560"/>
+          </a:xfrm>
+          <a:prstGeom prst="rect">
+            <a:avLst/>
+          </a:prstGeom>
+          <a:noFill/>
+        </p:spPr>
+        <p:txBody>
+          <a:bodyPr wrap="square">
+            <a:spAutoFit/>
+          </a:bodyPr>
+          <a:lstStyle/>
+          <a:p>
+            <a:pPr>
+              <a:defRPr sz="1800" b="0">
+                <a:solidFill>
+                  <a:srgbClr val="153B50"/>
+                </a:solidFill>
+                <a:latin typeface="Aptos"/>
+              </a:defRPr>
+            </a:pPr>
+            <a:r>
+              <a:t>The plotted KL objective tracks Gaussian SNE fitting. Native PCA, t-SNE, and UMAP objectives have different meanings. The earlier classifier log-loss charts are comparable across methods.</a:t>
+            </a:r>
+          </a:p>
+        </p:txBody>
+      </p:sp>
+    </p:spTree>
+  </p:cSld>
+  <p:clrMapOvr>
+    <a:masterClrMapping/>
+  </p:clrMapOvr>
+</p:sld>
+</file>
+
+<file path=ppt/slides/slide22.xml><?xml version="1.0" encoding="utf-8"?>
+<p:sld xmlns:a="http://schemas.openxmlformats.org/drawingml/2006/main" xmlns:p="http://schemas.openxmlformats.org/presentationml/2006/main" xmlns:r="http://schemas.openxmlformats.org/officeDocument/2006/relationships">
+  <p:cSld>
+    <p:spTree>
+      <p:nvGrpSpPr>
+        <p:cNvPr id="1" name=""/>
+        <p:cNvGrpSpPr/>
+        <p:nvPr/>
+      </p:nvGrpSpPr>
+      <p:grpSpPr/>
+      <p:sp>
+        <p:nvSpPr>
+          <p:cNvPr id="2" name="TextBox 1"/>
+          <p:cNvSpPr txBox="1"/>
+          <p:nvPr/>
+        </p:nvSpPr>
+        <p:spPr>
+          <a:xfrm>
+            <a:off x="502920" y="228600"/>
+            <a:ext cx="10972800" cy="640080"/>
+          </a:xfrm>
+          <a:prstGeom prst="rect">
+            <a:avLst/>
+          </a:prstGeom>
+          <a:noFill/>
+        </p:spPr>
+        <p:txBody>
+          <a:bodyPr wrap="square">
+            <a:spAutoFit/>
+          </a:bodyPr>
+          <a:lstStyle/>
+          <a:p>
+            <a:pPr>
+              <a:defRPr sz="2900" b="1">
+                <a:solidFill>
+                  <a:srgbClr val="153B50"/>
+                </a:solidFill>
+                <a:latin typeface="Aptos"/>
+              </a:defRPr>
+            </a:pPr>
+            <a:r>
+              <a:t>FROC AUC is not available</a:t>
+            </a:r>
+          </a:p>
+        </p:txBody>
+      </p:sp>
+      <p:pic>
+        <p:nvPicPr>
+          <p:cNvPr id="3" name="Picture 2" descr="froc_applicability.png"/>
+          <p:cNvPicPr>
+            <a:picLocks noChangeAspect="1"/>
+          </p:cNvPicPr>
+          <p:nvPr/>
+        </p:nvPicPr>
+        <p:blipFill>
+          <a:blip r:embed="rId2"/>
+          <a:stretch>
+            <a:fillRect/>
+          </a:stretch>
+        </p:blipFill>
+        <p:spPr>
+          <a:xfrm>
+            <a:off x="594360" y="1097280"/>
+            <a:ext cx="7315200" cy="2817280"/>
+          </a:xfrm>
+          <a:prstGeom prst="rect">
+            <a:avLst/>
+          </a:prstGeom>
+        </p:spPr>
+      </p:pic>
+      <p:sp>
+        <p:nvSpPr>
+          <p:cNvPr id="4" name="TextBox 3"/>
+          <p:cNvSpPr txBox="1"/>
+          <p:nvPr/>
+        </p:nvSpPr>
+        <p:spPr>
+          <a:xfrm>
+            <a:off x="8092440" y="1325880"/>
+            <a:ext cx="3520440" cy="4480560"/>
+          </a:xfrm>
+          <a:prstGeom prst="rect">
+            <a:avLst/>
+          </a:prstGeom>
+          <a:noFill/>
+        </p:spPr>
+        <p:txBody>
+          <a:bodyPr wrap="square">
+            <a:spAutoFit/>
+          </a:bodyPr>
+          <a:lstStyle/>
+          <a:p>
+            <a:pPr>
+              <a:defRPr sz="1800" b="0">
+                <a:solidFill>
+                  <a:srgbClr val="153B50"/>
+                </a:solidFill>
+                <a:latin typeface="Aptos"/>
+              </a:defRPr>
+            </a:pPr>
+            <a:r>
+              <a:t>ROC AUC is reported. A valid FROC needs scored candidate lesion locations and false positives per image. These tables have one label and one score per record.</a:t>
+            </a:r>
+          </a:p>
+        </p:txBody>
+      </p:sp>
+    </p:spTree>
+  </p:cSld>
+  <p:clrMapOvr>
+    <a:masterClrMapping/>
+  </p:clrMapOvr>
+</p:sld>
+</file>
+
+<file path=ppt/slides/slide23.xml><?xml version="1.0" encoding="utf-8"?>
+<p:sld xmlns:a="http://schemas.openxmlformats.org/drawingml/2006/main" xmlns:p="http://schemas.openxmlformats.org/presentationml/2006/main" xmlns:r="http://schemas.openxmlformats.org/officeDocument/2006/relationships">
+  <p:cSld>
+    <p:spTree>
+      <p:nvGrpSpPr>
+        <p:cNvPr id="1" name=""/>
+        <p:cNvGrpSpPr/>
+        <p:nvPr/>
+      </p:nvGrpSpPr>
+      <p:grpSpPr/>
+      <p:sp>
+        <p:nvSpPr>
+          <p:cNvPr id="2" name="TextBox 1"/>
+          <p:cNvSpPr txBox="1"/>
+          <p:nvPr/>
+        </p:nvSpPr>
+        <p:spPr>
+          <a:xfrm>
+            <a:off x="502920" y="228600"/>
+            <a:ext cx="10972800" cy="640080"/>
+          </a:xfrm>
+          <a:prstGeom prst="rect">
+            <a:avLst/>
+          </a:prstGeom>
+          <a:noFill/>
+        </p:spPr>
+        <p:txBody>
+          <a:bodyPr wrap="square">
+            <a:spAutoFit/>
+          </a:bodyPr>
+          <a:lstStyle/>
+          <a:p>
+            <a:pPr>
+              <a:defRPr sz="2900" b="1">
+                <a:solidFill>
+                  <a:srgbClr val="153B50"/>
+                </a:solidFill>
+                <a:latin typeface="Aptos"/>
+              </a:defRPr>
+            </a:pPr>
+            <a:r>
+              <a:t>Statistical tests are exploratory</a:t>
+            </a:r>
+          </a:p>
+        </p:txBody>
+      </p:sp>
+      <p:sp>
+        <p:nvSpPr>
+          <p:cNvPr id="3" name="TextBox 2"/>
+          <p:cNvSpPr txBox="1"/>
+          <p:nvPr/>
+        </p:nvSpPr>
+        <p:spPr>
+          <a:xfrm>
+            <a:off x="731520" y="1234440"/>
+            <a:ext cx="10789920" cy="4846320"/>
+          </a:xfrm>
+          <a:prstGeom prst="rect">
+            <a:avLst/>
+          </a:prstGeom>
+          <a:noFill/>
+        </p:spPr>
+        <p:txBody>
+          <a:bodyPr wrap="square">
+            <a:spAutoFit/>
+          </a:bodyPr>
+          <a:lstStyle/>
+          <a:p>
+            <a:pPr>
+              <a:defRPr sz="2100" b="0">
+                <a:solidFill>
+                  <a:srgbClr val="153B50"/>
+                </a:solidFill>
+                <a:latin typeface="Aptos"/>
+              </a:defRPr>
+            </a:pPr>
+            <a:r>
+              <a:t>Repeated-measures ANOVA of AUC: F(8,40)=0.673, p=0.712. Descriptive MANOVA method term: Wilks' lambda=0.840, p=0.945.</a:t>
+            </a:r>
+            <a:br/>
+            <a:br/>
+            <a:r>
+              <a:t>Paired t, Wilcoxon, and McNemar z comparisons are in the repository. Three overlapping splits have low power. MANOVA's independence assumption is violated. Read all p values as diagnostics.</a:t>
+            </a:r>
+          </a:p>
+        </p:txBody>
+      </p:sp>
+    </p:spTree>
+  </p:cSld>
+  <p:clrMapOvr>
+    <a:masterClrMapping/>
+  </p:clrMapOvr>
+</p:sld>
+</file>
+
+<file path=ppt/slides/slide24.xml><?xml version="1.0" encoding="utf-8"?>
+<p:sld xmlns:a="http://schemas.openxmlformats.org/drawingml/2006/main" xmlns:p="http://schemas.openxmlformats.org/presentationml/2006/main" xmlns:r="http://schemas.openxmlformats.org/officeDocument/2006/relationships">
+  <p:cSld>
+    <p:spTree>
+      <p:nvGrpSpPr>
+        <p:cNvPr id="1" name=""/>
+        <p:cNvGrpSpPr/>
+        <p:nvPr/>
+      </p:nvGrpSpPr>
+      <p:grpSpPr/>
+      <p:sp>
+        <p:nvSpPr>
+          <p:cNvPr id="2" name="TextBox 1"/>
+          <p:cNvSpPr txBox="1"/>
+          <p:nvPr/>
+        </p:nvSpPr>
+        <p:spPr>
+          <a:xfrm>
+            <a:off x="502920" y="228600"/>
+            <a:ext cx="10972800" cy="640080"/>
+          </a:xfrm>
+          <a:prstGeom prst="rect">
+            <a:avLst/>
+          </a:prstGeom>
+          <a:noFill/>
+        </p:spPr>
+        <p:txBody>
+          <a:bodyPr wrap="square">
+            <a:spAutoFit/>
+          </a:bodyPr>
+          <a:lstStyle/>
+          <a:p>
+            <a:pPr>
+              <a:defRPr sz="2900" b="1">
+                <a:solidFill>
+                  <a:srgbClr val="153B50"/>
+                </a:solidFill>
+                <a:latin typeface="Aptos"/>
+              </a:defRPr>
+            </a:pPr>
+            <a:r>
+              <a:t>What counts as good or bad evidence here</a:t>
+            </a:r>
+          </a:p>
+        </p:txBody>
+      </p:sp>
+      <p:sp>
+        <p:nvSpPr>
+          <p:cNvPr id="3" name="TextBox 2"/>
+          <p:cNvSpPr txBox="1"/>
+          <p:nvPr/>
+        </p:nvSpPr>
+        <p:spPr>
+          <a:xfrm>
+            <a:off x="731520" y="1234440"/>
+            <a:ext cx="10789920" cy="4846320"/>
+          </a:xfrm>
+          <a:prstGeom prst="rect">
+            <a:avLst/>
+          </a:prstGeom>
+          <a:noFill/>
+        </p:spPr>
+        <p:txBody>
+          <a:bodyPr wrap="square">
+            <a:spAutoFit/>
+          </a:bodyPr>
+          <a:lstStyle/>
+          <a:p>
+            <a:pPr>
+              <a:defRPr sz="2100" b="0">
+                <a:solidFill>
+                  <a:srgbClr val="153B50"/>
+                </a:solidFill>
+                <a:latin typeface="Aptos"/>
+              </a:defRPr>
+            </a:pPr>
+            <a:r>
+              <a:t>A good result would combine high held-out AUC with useful sensitivity and precision, low log loss, stable parameters, and an acceptable CPU cost. None of these pilot AUCs exceeds 0.65.</a:t>
+            </a:r>
+            <a:br/>
+            <a:br/>
+            <a:r>
+              <a:t>A method can look good on one metric and weak on another: SNE has the highest blood-cell accuracy but lower AUC than PCA; Isomap leads HAM AUC but its positive precision is only 0.134.</a:t>
+            </a:r>
+            <a:br/>
+            <a:br/>
+            <a:r>
+              <a:t>Three overlapping splits do not provide a reliable superiority claim. The statistical tests and plots describe this experiment, not clinical readiness.</a:t>
+            </a:r>
+          </a:p>
+        </p:txBody>
+      </p:sp>
+    </p:spTree>
+  </p:cSld>
+  <p:clrMapOvr>
+    <a:masterClrMapping/>
+  </p:clrMapOvr>
+</p:sld>
+</file>
+
+<file path=ppt/slides/slide25.xml><?xml version="1.0" encoding="utf-8"?>
+<p:sld xmlns:a="http://schemas.openxmlformats.org/drawingml/2006/main" xmlns:p="http://schemas.openxmlformats.org/presentationml/2006/main" xmlns:r="http://schemas.openxmlformats.org/officeDocument/2006/relationships">
+  <p:cSld>
+    <p:spTree>
+      <p:nvGrpSpPr>
+        <p:cNvPr id="1" name=""/>
+        <p:cNvGrpSpPr/>
+        <p:nvPr/>
+      </p:nvGrpSpPr>
+      <p:grpSpPr/>
+      <p:sp>
+        <p:nvSpPr>
+          <p:cNvPr id="2" name="TextBox 1"/>
+          <p:cNvSpPr txBox="1"/>
+          <p:nvPr/>
+        </p:nvSpPr>
+        <p:spPr>
+          <a:xfrm>
+            <a:off x="502920" y="228600"/>
+            <a:ext cx="10972800" cy="640080"/>
+          </a:xfrm>
+          <a:prstGeom prst="rect">
+            <a:avLst/>
+          </a:prstGeom>
+          <a:noFill/>
+        </p:spPr>
+        <p:txBody>
+          <a:bodyPr wrap="square">
+            <a:spAutoFit/>
+          </a:bodyPr>
+          <a:lstStyle/>
+          <a:p>
+            <a:pPr>
+              <a:defRPr sz="2900" b="1">
+                <a:solidFill>
+                  <a:srgbClr val="153B50"/>
+                </a:solidFill>
+                <a:latin typeface="Aptos"/>
+              </a:defRPr>
+            </a:pPr>
+            <a:r>
+              <a:t>Interpretation and next steps</a:t>
+            </a:r>
+          </a:p>
+        </p:txBody>
+      </p:sp>
+      <p:sp>
+        <p:nvSpPr>
+          <p:cNvPr id="3" name="TextBox 2"/>
+          <p:cNvSpPr txBox="1"/>
+          <p:nvPr/>
+        </p:nvSpPr>
+        <p:spPr>
+          <a:xfrm>
+            <a:off x="731520" y="1234440"/>
+            <a:ext cx="10789920" cy="4846320"/>
+          </a:xfrm>
+          <a:prstGeom prst="rect">
+            <a:avLst/>
+          </a:prstGeom>
+          <a:noFill/>
+        </p:spPr>
+        <p:txBody>
+          <a:bodyPr wrap="square">
+            <a:spAutoFit/>
+          </a:bodyPr>
+          <a:lstStyle/>
+          <a:p>
+            <a:pPr>
+              <a:defRPr sz="2100" b="0">
+                <a:solidFill>
+                  <a:srgbClr val="153B50"/>
+                </a:solidFill>
+                <a:latin typeface="Aptos"/>
+              </a:defRPr>
+            </a:pPr>
+            <a:r>
+              <a:t>Performance changes with split and parameter choice. The 8 × 8 lesion images limit clinical meaning. The blood-cell table lacks patient-level validation.</a:t>
+            </a:r>
+            <a:br/>
+            <a:br/>
+            <a:r>
+              <a:t>For a journal study: use original or validated features, external cohorts, nested tuning, uncertainty intervals, and lesion locations if FROC is required.</a:t>
+            </a:r>
+          </a:p>
+        </p:txBody>
+      </p:sp>
+      <p:sp>
+        <p:nvSpPr>
+          <p:cNvPr id="4" name="TextBox 3"/>
+          <p:cNvSpPr txBox="1"/>
+          <p:nvPr/>
+        </p:nvSpPr>
+        <p:spPr>
+          <a:xfrm>
+            <a:off x="594360" y="6446520"/>
+            <a:ext cx="10972800" cy="274320"/>
+          </a:xfrm>
+          <a:prstGeom prst="rect">
+            <a:avLst/>
+          </a:prstGeom>
+          <a:noFill/>
+        </p:spPr>
+        <p:txBody>
+          <a:bodyPr wrap="square">
+            <a:spAutoFit/>
+          </a:bodyPr>
+          <a:lstStyle/>
+          <a:p>
+            <a:pPr>
+              <a:defRPr sz="1000" b="0">
+                <a:solidFill>
+                  <a:srgbClr val="5C6770"/>
+                </a:solidFill>
+                <a:latin typeface="Aptos"/>
+              </a:defRPr>
+            </a:pPr>
+            <a:r>
+              <a:t>Sources and exact numbers: AML_research_report.docx and results/primary_summary.csv</a:t>
+            </a:r>
+          </a:p>
+        </p:txBody>
+      </p:sp>
+    </p:spTree>
+  </p:cSld>
+  <p:clrMapOvr>
+    <a:masterClrMapping/>
+  </p:clrMapOvr>
+</p:sld>
+</file>
+
 <file path=ppt/slides/slide3.xml><?xml version="1.0" encoding="utf-8"?>
 <p:sld xmlns:a="http://schemas.openxmlformats.org/drawingml/2006/main" xmlns:p="http://schemas.openxmlformats.org/presentationml/2006/main" xmlns:r="http://schemas.openxmlformats.org/officeDocument/2006/relationships">
   <p:cSld>
@@ -4118,69 +5357,21 @@
               </a:defRPr>
             </a:pPr>
             <a:r>
-              <a:t>HAM10000: accuracy and loss</a:t>
-            </a:r>
-          </a:p>
-        </p:txBody>
-      </p:sp>
-      <p:pic>
-        <p:nvPicPr>
-          <p:cNvPr id="3" name="Picture 2" descr="HAM10000_accuracy.png"/>
-          <p:cNvPicPr>
-            <a:picLocks noChangeAspect="1"/>
-          </p:cNvPicPr>
-          <p:nvPr/>
-        </p:nvPicPr>
-        <p:blipFill>
-          <a:blip r:embed="rId2"/>
-          <a:stretch>
-            <a:fillRect/>
-          </a:stretch>
-        </p:blipFill>
-        <p:spPr>
-          <a:xfrm>
-            <a:off x="502920" y="1051560"/>
-            <a:ext cx="5577840" cy="2244172"/>
-          </a:xfrm>
-          <a:prstGeom prst="rect">
-            <a:avLst/>
-          </a:prstGeom>
-        </p:spPr>
-      </p:pic>
-      <p:pic>
-        <p:nvPicPr>
-          <p:cNvPr id="4" name="Picture 3" descr="HAM10000_loss.png"/>
-          <p:cNvPicPr>
-            <a:picLocks noChangeAspect="1"/>
-          </p:cNvPicPr>
-          <p:nvPr/>
-        </p:nvPicPr>
-        <p:blipFill>
-          <a:blip r:embed="rId3"/>
-          <a:stretch>
-            <a:fillRect/>
-          </a:stretch>
-        </p:blipFill>
-        <p:spPr>
-          <a:xfrm>
-            <a:off x="6217920" y="1051560"/>
-            <a:ext cx="5486400" cy="2207383"/>
-          </a:xfrm>
-          <a:prstGeom prst="rect">
-            <a:avLst/>
-          </a:prstGeom>
-        </p:spPr>
-      </p:pic>
-      <p:sp>
-        <p:nvSpPr>
-          <p:cNvPr id="5" name="TextBox 4"/>
+              <a:t>The comparison measures retained class information</a:t>
+            </a:r>
+          </a:p>
+        </p:txBody>
+      </p:sp>
+      <p:sp>
+        <p:nvSpPr>
+          <p:cNvPr id="3" name="TextBox 2"/>
           <p:cNvSpPr txBox="1"/>
           <p:nvPr/>
         </p:nvSpPr>
         <p:spPr>
           <a:xfrm>
-            <a:off x="685800" y="4892040"/>
-            <a:ext cx="10881360" cy="1051560"/>
+            <a:off x="731520" y="1234440"/>
+            <a:ext cx="10789920" cy="4846320"/>
           </a:xfrm>
           <a:prstGeom prst="rect">
             <a:avLst/>
@@ -4194,7 +5385,7 @@
           <a:lstStyle/>
           <a:p>
             <a:pPr>
-              <a:defRPr sz="1700" b="0">
+              <a:defRPr sz="2100" b="0">
                 <a:solidFill>
                   <a:srgbClr val="153B50"/>
                 </a:solidFill>
@@ -4202,7 +5393,17 @@
               </a:defRPr>
             </a:pPr>
             <a:r>
-              <a:t>Highest mean AUC: Isomap, 0.649. The two charts show why accuracy and probability loss should be read together.</a:t>
+              <a:t>Input features are standardized using the training records. Each algorithm reduces them to two coordinates. The same balanced logistic regression then predicts held-out labels.</a:t>
+            </a:r>
+            <a:br/>
+            <a:br/>
+            <a:r>
+              <a:t>AUC asks whether positives generally receive higher scores than negatives across thresholds. Accuracy evaluates one fixed threshold. Log loss penalizes confident wrong probabilities. CPU time covers the full fitted pipeline.</a:t>
+            </a:r>
+            <a:br/>
+            <a:br/>
+            <a:r>
+              <a:t>A visually neat map is insufficient evidence unless held-out prediction also improves.</a:t>
             </a:r>
           </a:p>
         </p:txBody>
@@ -4256,59 +5457,57 @@
               </a:defRPr>
             </a:pPr>
             <a:r>
-              <a:t>HAM10000: ROC and confusion matrices</a:t>
-            </a:r>
-          </a:p>
-        </p:txBody>
-      </p:sp>
-      <p:pic>
-        <p:nvPicPr>
-          <p:cNvPr id="3" name="Picture 2" descr="HAM10000_roc.png"/>
-          <p:cNvPicPr>
-            <a:picLocks noChangeAspect="1"/>
-          </p:cNvPicPr>
-          <p:nvPr/>
-        </p:nvPicPr>
-        <p:blipFill>
-          <a:blip r:embed="rId2"/>
-          <a:stretch>
-            <a:fillRect/>
-          </a:stretch>
-        </p:blipFill>
-        <p:spPr>
-          <a:xfrm>
-            <a:off x="502920" y="1051560"/>
-            <a:ext cx="5577840" cy="4395580"/>
-          </a:xfrm>
-          <a:prstGeom prst="rect">
-            <a:avLst/>
-          </a:prstGeom>
-        </p:spPr>
-      </p:pic>
-      <p:pic>
-        <p:nvPicPr>
-          <p:cNvPr id="4" name="Picture 3" descr="HAM10000_confusion.png"/>
-          <p:cNvPicPr>
-            <a:picLocks noChangeAspect="1"/>
-          </p:cNvPicPr>
-          <p:nvPr/>
-        </p:nvPicPr>
-        <p:blipFill>
-          <a:blip r:embed="rId3"/>
-          <a:stretch>
-            <a:fillRect/>
-          </a:stretch>
-        </p:blipFill>
-        <p:spPr>
-          <a:xfrm>
-            <a:off x="6217920" y="1051560"/>
-            <a:ext cx="5486400" cy="5481010"/>
-          </a:xfrm>
-          <a:prstGeom prst="rect">
-            <a:avLst/>
-          </a:prstGeom>
-        </p:spPr>
-      </p:pic>
+              <a:t>Global geometry: PCA, kernel PCA, MDS, PCoA</a:t>
+            </a:r>
+          </a:p>
+        </p:txBody>
+      </p:sp>
+      <p:sp>
+        <p:nvSpPr>
+          <p:cNvPr id="3" name="TextBox 2"/>
+          <p:cNvSpPr txBox="1"/>
+          <p:nvPr/>
+        </p:nvSpPr>
+        <p:spPr>
+          <a:xfrm>
+            <a:off x="731520" y="1234440"/>
+            <a:ext cx="10789920" cy="4846320"/>
+          </a:xfrm>
+          <a:prstGeom prst="rect">
+            <a:avLst/>
+          </a:prstGeom>
+          <a:noFill/>
+        </p:spPr>
+        <p:txBody>
+          <a:bodyPr wrap="square">
+            <a:spAutoFit/>
+          </a:bodyPr>
+          <a:lstStyle/>
+          <a:p>
+            <a:pPr>
+              <a:defRPr sz="2100" b="0">
+                <a:solidFill>
+                  <a:srgbClr val="153B50"/>
+                </a:solidFill>
+                <a:latin typeface="Aptos"/>
+              </a:defRPr>
+            </a:pPr>
+            <a:r>
+              <a:t>PCA keeps directions with the most variance. It is fast, but large variance need not represent disease.</a:t>
+            </a:r>
+            <a:br/>
+            <a:br/>
+            <a:r>
+              <a:t>Kernel PCA uses an RBF similarity so curved patterns can become separable. Its gamma setting determines the scale of similarity.</a:t>
+            </a:r>
+            <a:br/>
+            <a:br/>
+            <a:r>
+              <a:t>MDS tries to preserve Euclidean distances between every pair. PCoA eigendecomposes a centered distance matrix; here cosine distance is primary. Both can devote two dimensions to variation unrelated to the label.</a:t>
+            </a:r>
+          </a:p>
+        </p:txBody>
+      </p:sp>
     </p:spTree>
   </p:cSld>
   <p:clrMapOvr>
@@ -4358,69 +5557,21 @@
               </a:defRPr>
             </a:pPr>
             <a:r>
-              <a:t>Blood cell: accuracy and loss</a:t>
-            </a:r>
-          </a:p>
-        </p:txBody>
-      </p:sp>
-      <p:pic>
-        <p:nvPicPr>
-          <p:cNvPr id="3" name="Picture 2" descr="Blood_cell_accuracy.png"/>
-          <p:cNvPicPr>
-            <a:picLocks noChangeAspect="1"/>
-          </p:cNvPicPr>
-          <p:nvPr/>
-        </p:nvPicPr>
-        <p:blipFill>
-          <a:blip r:embed="rId2"/>
-          <a:stretch>
-            <a:fillRect/>
-          </a:stretch>
-        </p:blipFill>
-        <p:spPr>
-          <a:xfrm>
-            <a:off x="502920" y="1051560"/>
-            <a:ext cx="5577840" cy="2244172"/>
-          </a:xfrm>
-          <a:prstGeom prst="rect">
-            <a:avLst/>
-          </a:prstGeom>
-        </p:spPr>
-      </p:pic>
-      <p:pic>
-        <p:nvPicPr>
-          <p:cNvPr id="4" name="Picture 3" descr="Blood_cell_loss.png"/>
-          <p:cNvPicPr>
-            <a:picLocks noChangeAspect="1"/>
-          </p:cNvPicPr>
-          <p:nvPr/>
-        </p:nvPicPr>
-        <p:blipFill>
-          <a:blip r:embed="rId3"/>
-          <a:stretch>
-            <a:fillRect/>
-          </a:stretch>
-        </p:blipFill>
-        <p:spPr>
-          <a:xfrm>
-            <a:off x="6217920" y="1051560"/>
-            <a:ext cx="5486400" cy="2207383"/>
-          </a:xfrm>
-          <a:prstGeom prst="rect">
-            <a:avLst/>
-          </a:prstGeom>
-        </p:spPr>
-      </p:pic>
-      <p:sp>
-        <p:nvSpPr>
-          <p:cNvPr id="5" name="TextBox 4"/>
+              <a:t>Local geometry: SNE, t-SNE, hybrid, UMAP, Isomap</a:t>
+            </a:r>
+          </a:p>
+        </p:txBody>
+      </p:sp>
+      <p:sp>
+        <p:nvSpPr>
+          <p:cNvPr id="3" name="TextBox 2"/>
           <p:cNvSpPr txBox="1"/>
           <p:nvPr/>
         </p:nvSpPr>
         <p:spPr>
           <a:xfrm>
-            <a:off x="685800" y="4892040"/>
-            <a:ext cx="10881360" cy="1051560"/>
+            <a:off x="731520" y="1234440"/>
+            <a:ext cx="10789920" cy="4846320"/>
           </a:xfrm>
           <a:prstGeom prst="rect">
             <a:avLst/>
@@ -4434,7 +5585,7 @@
           <a:lstStyle/>
           <a:p>
             <a:pPr>
-              <a:defRPr sz="1700" b="0">
+              <a:defRPr sz="2100" b="0">
                 <a:solidFill>
                   <a:srgbClr val="153B50"/>
                 </a:solidFill>
@@ -4442,7 +5593,17 @@
               </a:defRPr>
             </a:pPr>
             <a:r>
-              <a:t>Highest mean AUC: PCA, 0.630. The two charts show why accuracy and probability loss should be read together.</a:t>
+              <a:t>SNE and t-SNE match neighbor probabilities. t-SNE's heavy tail reduces crowding; perplexity controls neighborhood scale. PCA plus t-SNE first filters the inputs to at most 30 components.</a:t>
+            </a:r>
+            <a:br/>
+            <a:br/>
+            <a:r>
+              <a:t>UMAP builds a fuzzy neighbor graph; its neighbor count controls how local the map is. Isomap uses graph shortest paths to estimate geodesic distances.</a:t>
+            </a:r>
+            <a:br/>
+            <a:br/>
+            <a:r>
+              <a:t>These maps can reveal local structure, but they may distort global distances and change when the neighborhood parameter changes.</a:t>
             </a:r>
           </a:p>
         </p:txBody>
@@ -4496,59 +5657,57 @@
               </a:defRPr>
             </a:pPr>
             <a:r>
-              <a:t>Blood cell: ROC and confusion matrices</a:t>
-            </a:r>
-          </a:p>
-        </p:txBody>
-      </p:sp>
-      <p:pic>
-        <p:nvPicPr>
-          <p:cNvPr id="3" name="Picture 2" descr="Blood_cell_roc.png"/>
-          <p:cNvPicPr>
-            <a:picLocks noChangeAspect="1"/>
-          </p:cNvPicPr>
-          <p:nvPr/>
-        </p:nvPicPr>
-        <p:blipFill>
-          <a:blip r:embed="rId2"/>
-          <a:stretch>
-            <a:fillRect/>
-          </a:stretch>
-        </p:blipFill>
-        <p:spPr>
-          <a:xfrm>
-            <a:off x="502920" y="1051560"/>
-            <a:ext cx="5577840" cy="4395580"/>
-          </a:xfrm>
-          <a:prstGeom prst="rect">
-            <a:avLst/>
-          </a:prstGeom>
-        </p:spPr>
-      </p:pic>
-      <p:pic>
-        <p:nvPicPr>
-          <p:cNvPr id="4" name="Picture 3" descr="Blood_cell_confusion.png"/>
-          <p:cNvPicPr>
-            <a:picLocks noChangeAspect="1"/>
-          </p:cNvPicPr>
-          <p:nvPr/>
-        </p:nvPicPr>
-        <p:blipFill>
-          <a:blip r:embed="rId3"/>
-          <a:stretch>
-            <a:fillRect/>
-          </a:stretch>
-        </p:blipFill>
-        <p:spPr>
-          <a:xfrm>
-            <a:off x="6217920" y="1051560"/>
-            <a:ext cx="5486400" cy="5481010"/>
-          </a:xfrm>
-          <a:prstGeom prst="rect">
-            <a:avLst/>
-          </a:prstGeom>
-        </p:spPr>
-      </p:pic>
+              <a:t>How unseen test records enter each map</a:t>
+            </a:r>
+          </a:p>
+        </p:txBody>
+      </p:sp>
+      <p:sp>
+        <p:nvSpPr>
+          <p:cNvPr id="3" name="TextBox 2"/>
+          <p:cNvSpPr txBox="1"/>
+          <p:nvPr/>
+        </p:nvSpPr>
+        <p:spPr>
+          <a:xfrm>
+            <a:off x="731520" y="1234440"/>
+            <a:ext cx="10789920" cy="4846320"/>
+          </a:xfrm>
+          <a:prstGeom prst="rect">
+            <a:avLst/>
+          </a:prstGeom>
+          <a:noFill/>
+        </p:spPr>
+        <p:txBody>
+          <a:bodyPr wrap="square">
+            <a:spAutoFit/>
+          </a:bodyPr>
+          <a:lstStyle/>
+          <a:p>
+            <a:pPr>
+              <a:defRPr sz="2100" b="0">
+                <a:solidFill>
+                  <a:srgbClr val="153B50"/>
+                </a:solidFill>
+                <a:latin typeface="Aptos"/>
+              </a:defRPr>
+            </a:pPr>
+            <a:r>
+              <a:t>PCA, kernel PCA, UMAP, and Isomap transform new records directly. PCoA uses a distance-based Gower extension.</a:t>
+            </a:r>
+            <a:br/>
+            <a:br/>
+            <a:r>
+              <a:t>The chosen SNE, t-SNE, and MDS implementations have no native test transform. A five-neighbor weighted regressor estimates test coordinates from their training maps.</a:t>
+            </a:r>
+            <a:br/>
+            <a:br/>
+            <a:r>
+              <a:t>The measured ranking therefore compares complete representation pipelines, including this approximation. It does not compare only the training maps.</a:t>
+            </a:r>
+          </a:p>
+        </p:txBody>
+      </p:sp>
     </p:spTree>
   </p:cSld>
   <p:clrMapOvr>
@@ -4598,69 +5757,21 @@
               </a:defRPr>
             </a:pPr>
             <a:r>
-              <a:t>CPU time has a steep method cost</a:t>
-            </a:r>
-          </a:p>
-        </p:txBody>
-      </p:sp>
-      <p:pic>
-        <p:nvPicPr>
-          <p:cNvPr id="3" name="Picture 2" descr="HAM10000_cpu.png"/>
-          <p:cNvPicPr>
-            <a:picLocks noChangeAspect="1"/>
-          </p:cNvPicPr>
-          <p:nvPr/>
-        </p:nvPicPr>
-        <p:blipFill>
-          <a:blip r:embed="rId2"/>
-          <a:stretch>
-            <a:fillRect/>
-          </a:stretch>
-        </p:blipFill>
-        <p:spPr>
-          <a:xfrm>
-            <a:off x="502920" y="1051560"/>
-            <a:ext cx="5577840" cy="2244172"/>
-          </a:xfrm>
-          <a:prstGeom prst="rect">
-            <a:avLst/>
-          </a:prstGeom>
-        </p:spPr>
-      </p:pic>
-      <p:pic>
-        <p:nvPicPr>
-          <p:cNvPr id="4" name="Picture 3" descr="Blood_cell_cpu.png"/>
-          <p:cNvPicPr>
-            <a:picLocks noChangeAspect="1"/>
-          </p:cNvPicPr>
-          <p:nvPr/>
-        </p:nvPicPr>
-        <p:blipFill>
-          <a:blip r:embed="rId3"/>
-          <a:stretch>
-            <a:fillRect/>
-          </a:stretch>
-        </p:blipFill>
-        <p:spPr>
-          <a:xfrm>
-            <a:off x="6217920" y="1051560"/>
-            <a:ext cx="5486400" cy="2207383"/>
-          </a:xfrm>
-          <a:prstGeom prst="rect">
-            <a:avLst/>
-          </a:prstGeom>
-        </p:spPr>
-      </p:pic>
-      <p:sp>
-        <p:nvSpPr>
-          <p:cNvPr id="5" name="TextBox 4"/>
+              <a:t>Method readings: PCA through the hybrid</a:t>
+            </a:r>
+          </a:p>
+        </p:txBody>
+      </p:sp>
+      <p:sp>
+        <p:nvSpPr>
+          <p:cNvPr id="3" name="TextBox 2"/>
           <p:cNvSpPr txBox="1"/>
           <p:nvPr/>
         </p:nvSpPr>
         <p:spPr>
           <a:xfrm>
-            <a:off x="685800" y="4892040"/>
-            <a:ext cx="10881360" cy="1051560"/>
+            <a:off x="731520" y="1234440"/>
+            <a:ext cx="10789920" cy="4846320"/>
           </a:xfrm>
           <a:prstGeom prst="rect">
             <a:avLst/>
@@ -4674,7 +5785,7 @@
           <a:lstStyle/>
           <a:p>
             <a:pPr>
-              <a:defRPr sz="1700" b="0">
+              <a:defRPr sz="2100" b="0">
                 <a:solidFill>
                   <a:srgbClr val="153B50"/>
                 </a:solidFill>
@@ -4682,7 +5793,27 @@
               </a:defRPr>
             </a:pPr>
             <a:r>
-              <a:t>PCA and kernel PCA are fastest in this sample-size range. UMAP, SNE, and t-SNE require substantially more CPU time. UMAP's first compilation is measured separately.</a:t>
+              <a:t>PCA: blood-cell AUC 0.630, the best there. A simple linear map may suffice for these selected features; it is weakest on HAM AUC at 0.602.</a:t>
+            </a:r>
+            <a:br/>
+            <a:br/>
+            <a:r>
+              <a:t>Kernel PCA: 0.638 HAM, 0.624 blood. Curved RBF similarities help modestly, with kernel scale affecting the map.</a:t>
+            </a:r>
+            <a:br/>
+            <a:br/>
+            <a:r>
+              <a:t>SNE: 0.616 HAM, 0.581 blood. Local-neighbor matching does not consistently retain the label signal.</a:t>
+            </a:r>
+            <a:br/>
+            <a:br/>
+            <a:r>
+              <a:t>t-SNE: 0.638 HAM, 0.622 blood. Better than SNE on both, but its approximate test transform limits interpretation.</a:t>
+            </a:r>
+            <a:br/>
+            <a:br/>
+            <a:r>
+              <a:t>PCA plus t-SNE: 0.632 HAM, 0.616 blood. The preprocessing step shows no gain over t-SNE in this pilot.</a:t>
             </a:r>
           </a:p>
         </p:txBody>

</xml_diff>

<commit_message>
Expand AML presentation with model and eleven-method visuals
</commit_message>
<xml_diff>
--- a/deliverables/AML_presentation.pptx
+++ b/deliverables/AML_presentation.pptx
@@ -30,6 +30,13 @@
     <p:sldId id="278" r:id="rId29"/>
     <p:sldId id="279" r:id="rId30"/>
     <p:sldId id="280" r:id="rId31"/>
+    <p:sldId id="281" r:id="rId32"/>
+    <p:sldId id="282" r:id="rId33"/>
+    <p:sldId id="283" r:id="rId34"/>
+    <p:sldId id="284" r:id="rId35"/>
+    <p:sldId id="285" r:id="rId36"/>
+    <p:sldId id="286" r:id="rId37"/>
+    <p:sldId id="287" r:id="rId38"/>
   </p:sldIdLst>
   <p:sldSz cx="12191695" cy="6858000" type="screen4x3"/>
   <p:notesSz cx="6858000" cy="9144000"/>
@@ -3183,7 +3190,7 @@
             </a:r>
             <a:br/>
             <a:r>
-              <a:t>Measured pilot comparison | 21 October 2026</a:t>
+              <a:t>Nine-method pilot and eleven-method notebook extension | 26 October 2026</a:t>
             </a:r>
           </a:p>
         </p:txBody>
@@ -3237,7 +3244,7 @@
               </a:defRPr>
             </a:pPr>
             <a:r>
-              <a:t>Method readings: UMAP through Isomap</a:t>
+              <a:t>How unseen test records enter each map</a:t>
             </a:r>
           </a:p>
         </p:txBody>
@@ -3273,27 +3280,17 @@
               </a:defRPr>
             </a:pPr>
             <a:r>
-              <a:t>UMAP: 0.645 HAM, 0.600 blood. The neighbor graph ranks lesions well, but costs about 2.24 CPU seconds per HAM run.</a:t>
-            </a:r>
-            <a:br/>
-            <a:br/>
-            <a:r>
-              <a:t>MDS: 0.620 HAM, 0.562 blood. Preserving global Euclidean distances gives the weakest blood-cell AUC.</a:t>
-            </a:r>
-            <a:br/>
-            <a:br/>
-            <a:r>
-              <a:t>PCoA: 0.633 HAM, 0.616 blood. Cosine distances give middle-ranking performance; a different distance changes the result.</a:t>
-            </a:r>
-            <a:br/>
-            <a:br/>
-            <a:r>
-              <a:t>Isomap: 0.649 HAM, 0.582 blood. Graph geodesics lead HAM AUC but transfer poorly to the blood-cell table.</a:t>
-            </a:r>
-            <a:br/>
-            <a:br/>
-            <a:r>
-              <a:t>The mechanisms above are interpretations of measured associations, not proven causes.</a:t>
+              <a:t>PCA, kernel PCA, UMAP, and Isomap transform new records directly. PCoA uses a distance-based Gower extension.</a:t>
+            </a:r>
+            <a:br/>
+            <a:br/>
+            <a:r>
+              <a:t>The chosen SNE, t-SNE, and MDS implementations have no native test transform. A five-neighbor weighted regressor estimates test coordinates from their training maps.</a:t>
+            </a:r>
+            <a:br/>
+            <a:br/>
+            <a:r>
+              <a:t>The measured ranking therefore compares complete representation pipelines, including this approximation. It does not compare only the training maps.</a:t>
             </a:r>
           </a:p>
         </p:txBody>
@@ -3347,69 +3344,21 @@
               </a:defRPr>
             </a:pPr>
             <a:r>
-              <a:t>HAM10000: accuracy and loss</a:t>
-            </a:r>
-          </a:p>
-        </p:txBody>
-      </p:sp>
-      <p:pic>
-        <p:nvPicPr>
-          <p:cNvPr id="3" name="Picture 2" descr="HAM10000_accuracy.png"/>
-          <p:cNvPicPr>
-            <a:picLocks noChangeAspect="1"/>
-          </p:cNvPicPr>
-          <p:nvPr/>
-        </p:nvPicPr>
-        <p:blipFill>
-          <a:blip r:embed="rId2"/>
-          <a:stretch>
-            <a:fillRect/>
-          </a:stretch>
-        </p:blipFill>
-        <p:spPr>
-          <a:xfrm>
-            <a:off x="502920" y="1051560"/>
-            <a:ext cx="5577840" cy="2244172"/>
-          </a:xfrm>
-          <a:prstGeom prst="rect">
-            <a:avLst/>
-          </a:prstGeom>
-        </p:spPr>
-      </p:pic>
-      <p:pic>
-        <p:nvPicPr>
-          <p:cNvPr id="4" name="Picture 3" descr="HAM10000_loss.png"/>
-          <p:cNvPicPr>
-            <a:picLocks noChangeAspect="1"/>
-          </p:cNvPicPr>
-          <p:nvPr/>
-        </p:nvPicPr>
-        <p:blipFill>
-          <a:blip r:embed="rId3"/>
-          <a:stretch>
-            <a:fillRect/>
-          </a:stretch>
-        </p:blipFill>
-        <p:spPr>
-          <a:xfrm>
-            <a:off x="6217920" y="1051560"/>
-            <a:ext cx="5486400" cy="2207383"/>
-          </a:xfrm>
-          <a:prstGeom prst="rect">
-            <a:avLst/>
-          </a:prstGeom>
-        </p:spPr>
-      </p:pic>
-      <p:sp>
-        <p:nvSpPr>
-          <p:cNvPr id="5" name="TextBox 4"/>
+              <a:t>Method readings: PCA through the hybrid</a:t>
+            </a:r>
+          </a:p>
+        </p:txBody>
+      </p:sp>
+      <p:sp>
+        <p:nvSpPr>
+          <p:cNvPr id="3" name="TextBox 2"/>
           <p:cNvSpPr txBox="1"/>
           <p:nvPr/>
         </p:nvSpPr>
         <p:spPr>
           <a:xfrm>
-            <a:off x="685800" y="4892040"/>
-            <a:ext cx="10881360" cy="1051560"/>
+            <a:off x="731520" y="1234440"/>
+            <a:ext cx="10789920" cy="4846320"/>
           </a:xfrm>
           <a:prstGeom prst="rect">
             <a:avLst/>
@@ -3423,7 +3372,7 @@
           <a:lstStyle/>
           <a:p>
             <a:pPr>
-              <a:defRPr sz="1700" b="0">
+              <a:defRPr sz="2100" b="0">
                 <a:solidFill>
                   <a:srgbClr val="153B50"/>
                 </a:solidFill>
@@ -3431,7 +3380,27 @@
               </a:defRPr>
             </a:pPr>
             <a:r>
-              <a:t>Highest mean AUC: Isomap, 0.649. The two charts show why accuracy and probability loss should be read together.</a:t>
+              <a:t>PCA: blood-cell AUC 0.630, the best there. A simple linear map may suffice for these selected features; it is weakest on HAM AUC at 0.602.</a:t>
+            </a:r>
+            <a:br/>
+            <a:br/>
+            <a:r>
+              <a:t>Kernel PCA: 0.638 HAM, 0.624 blood. Curved RBF similarities help modestly, with kernel scale affecting the map.</a:t>
+            </a:r>
+            <a:br/>
+            <a:br/>
+            <a:r>
+              <a:t>SNE: 0.616 HAM, 0.581 blood. Local-neighbor matching does not consistently retain the label signal.</a:t>
+            </a:r>
+            <a:br/>
+            <a:br/>
+            <a:r>
+              <a:t>t-SNE: 0.638 HAM, 0.622 blood. Better than SNE on both, but its approximate test transform limits interpretation.</a:t>
+            </a:r>
+            <a:br/>
+            <a:br/>
+            <a:r>
+              <a:t>PCA plus t-SNE: 0.632 HAM, 0.616 blood. The preprocessing step shows no gain over t-SNE in this pilot.</a:t>
             </a:r>
           </a:p>
         </p:txBody>
@@ -3485,59 +3454,67 @@
               </a:defRPr>
             </a:pPr>
             <a:r>
-              <a:t>HAM10000: ROC and confusion matrices</a:t>
-            </a:r>
-          </a:p>
-        </p:txBody>
-      </p:sp>
-      <p:pic>
-        <p:nvPicPr>
-          <p:cNvPr id="3" name="Picture 2" descr="HAM10000_roc.png"/>
-          <p:cNvPicPr>
-            <a:picLocks noChangeAspect="1"/>
-          </p:cNvPicPr>
-          <p:nvPr/>
-        </p:nvPicPr>
-        <p:blipFill>
-          <a:blip r:embed="rId2"/>
-          <a:stretch>
-            <a:fillRect/>
-          </a:stretch>
-        </p:blipFill>
-        <p:spPr>
-          <a:xfrm>
-            <a:off x="502920" y="1051560"/>
-            <a:ext cx="5577840" cy="4395580"/>
-          </a:xfrm>
-          <a:prstGeom prst="rect">
-            <a:avLst/>
-          </a:prstGeom>
-        </p:spPr>
-      </p:pic>
-      <p:pic>
-        <p:nvPicPr>
-          <p:cNvPr id="4" name="Picture 3" descr="HAM10000_confusion.png"/>
-          <p:cNvPicPr>
-            <a:picLocks noChangeAspect="1"/>
-          </p:cNvPicPr>
-          <p:nvPr/>
-        </p:nvPicPr>
-        <p:blipFill>
-          <a:blip r:embed="rId3"/>
-          <a:stretch>
-            <a:fillRect/>
-          </a:stretch>
-        </p:blipFill>
-        <p:spPr>
-          <a:xfrm>
-            <a:off x="6217920" y="1051560"/>
-            <a:ext cx="5486400" cy="5481010"/>
-          </a:xfrm>
-          <a:prstGeom prst="rect">
-            <a:avLst/>
-          </a:prstGeom>
-        </p:spPr>
-      </p:pic>
+              <a:t>Method readings: UMAP through Isomap</a:t>
+            </a:r>
+          </a:p>
+        </p:txBody>
+      </p:sp>
+      <p:sp>
+        <p:nvSpPr>
+          <p:cNvPr id="3" name="TextBox 2"/>
+          <p:cNvSpPr txBox="1"/>
+          <p:nvPr/>
+        </p:nvSpPr>
+        <p:spPr>
+          <a:xfrm>
+            <a:off x="731520" y="1234440"/>
+            <a:ext cx="10789920" cy="4846320"/>
+          </a:xfrm>
+          <a:prstGeom prst="rect">
+            <a:avLst/>
+          </a:prstGeom>
+          <a:noFill/>
+        </p:spPr>
+        <p:txBody>
+          <a:bodyPr wrap="square">
+            <a:spAutoFit/>
+          </a:bodyPr>
+          <a:lstStyle/>
+          <a:p>
+            <a:pPr>
+              <a:defRPr sz="2100" b="0">
+                <a:solidFill>
+                  <a:srgbClr val="153B50"/>
+                </a:solidFill>
+                <a:latin typeface="Aptos"/>
+              </a:defRPr>
+            </a:pPr>
+            <a:r>
+              <a:t>UMAP: 0.645 HAM, 0.600 blood. The neighbor graph ranks lesions well, but costs about 2.24 CPU seconds per HAM run.</a:t>
+            </a:r>
+            <a:br/>
+            <a:br/>
+            <a:r>
+              <a:t>MDS: 0.620 HAM, 0.562 blood. Preserving global Euclidean distances gives the weakest blood-cell AUC.</a:t>
+            </a:r>
+            <a:br/>
+            <a:br/>
+            <a:r>
+              <a:t>PCoA: 0.633 HAM, 0.616 blood. Cosine distances give middle-ranking performance; a different distance changes the result.</a:t>
+            </a:r>
+            <a:br/>
+            <a:br/>
+            <a:r>
+              <a:t>Isomap: 0.649 HAM, 0.582 blood. Graph geodesics lead HAM AUC but transfer poorly to the blood-cell table.</a:t>
+            </a:r>
+            <a:br/>
+            <a:br/>
+            <a:r>
+              <a:t>The mechanisms above are interpretations of measured associations, not proven causes.</a:t>
+            </a:r>
+          </a:p>
+        </p:txBody>
+      </p:sp>
     </p:spTree>
   </p:cSld>
   <p:clrMapOvr>
@@ -3587,21 +3564,69 @@
               </a:defRPr>
             </a:pPr>
             <a:r>
-              <a:t>HAM10000: better ranking, weak positive precision</a:t>
-            </a:r>
-          </a:p>
-        </p:txBody>
-      </p:sp>
-      <p:sp>
-        <p:nvSpPr>
-          <p:cNvPr id="3" name="TextBox 2"/>
+              <a:t>HAM10000: accuracy and loss</a:t>
+            </a:r>
+          </a:p>
+        </p:txBody>
+      </p:sp>
+      <p:pic>
+        <p:nvPicPr>
+          <p:cNvPr id="3" name="Picture 2" descr="HAM10000_accuracy.png"/>
+          <p:cNvPicPr>
+            <a:picLocks noChangeAspect="1"/>
+          </p:cNvPicPr>
+          <p:nvPr/>
+        </p:nvPicPr>
+        <p:blipFill>
+          <a:blip r:embed="rId2"/>
+          <a:stretch>
+            <a:fillRect/>
+          </a:stretch>
+        </p:blipFill>
+        <p:spPr>
+          <a:xfrm>
+            <a:off x="502920" y="1051560"/>
+            <a:ext cx="5577840" cy="2244172"/>
+          </a:xfrm>
+          <a:prstGeom prst="rect">
+            <a:avLst/>
+          </a:prstGeom>
+        </p:spPr>
+      </p:pic>
+      <p:pic>
+        <p:nvPicPr>
+          <p:cNvPr id="4" name="Picture 3" descr="HAM10000_loss.png"/>
+          <p:cNvPicPr>
+            <a:picLocks noChangeAspect="1"/>
+          </p:cNvPicPr>
+          <p:nvPr/>
+        </p:nvPicPr>
+        <p:blipFill>
+          <a:blip r:embed="rId3"/>
+          <a:stretch>
+            <a:fillRect/>
+          </a:stretch>
+        </p:blipFill>
+        <p:spPr>
+          <a:xfrm>
+            <a:off x="6217920" y="1051560"/>
+            <a:ext cx="5486400" cy="2207383"/>
+          </a:xfrm>
+          <a:prstGeom prst="rect">
+            <a:avLst/>
+          </a:prstGeom>
+        </p:spPr>
+      </p:pic>
+      <p:sp>
+        <p:nvSpPr>
+          <p:cNvPr id="5" name="TextBox 4"/>
           <p:cNvSpPr txBox="1"/>
           <p:nvPr/>
         </p:nvSpPr>
         <p:spPr>
           <a:xfrm>
-            <a:off x="731520" y="1234440"/>
-            <a:ext cx="10789920" cy="4846320"/>
+            <a:off x="685800" y="4892040"/>
+            <a:ext cx="10881360" cy="1051560"/>
           </a:xfrm>
           <a:prstGeom prst="rect">
             <a:avLst/>
@@ -3615,7 +3640,7 @@
           <a:lstStyle/>
           <a:p>
             <a:pPr>
-              <a:defRPr sz="2100" b="0">
+              <a:defRPr sz="1700" b="0">
                 <a:solidFill>
                   <a:srgbClr val="153B50"/>
                 </a:solidFill>
@@ -3623,17 +3648,7 @@
               </a:defRPr>
             </a:pPr>
             <a:r>
-              <a:t>Isomap leads mean ROC AUC at 0.649, versus 0.602 for PCA. A neighbor graph may retain class-related structure that the largest-variance PCA axes miss. The experiment does not establish that mechanism.</a:t>
-            </a:r>
-            <a:br/>
-            <a:br/>
-            <a:r>
-              <a:t>PCA has slightly higher accuracy, 0.609 versus 0.590. AUC measures ranking across thresholds, while accuracy uses the prespecified 0.5 threshold.</a:t>
-            </a:r>
-            <a:br/>
-            <a:br/>
-            <a:r>
-              <a:t>Isomap precision is 0.134: most positive calls are false positives. The 8 × 8 pixels and low melanoma prevalence limit clinical meaning.</a:t>
+              <a:t>Highest mean AUC: Isomap, 0.649. The two charts show why accuracy and probability loss should be read together.</a:t>
             </a:r>
           </a:p>
         </p:txBody>
@@ -3687,14 +3702,14 @@
               </a:defRPr>
             </a:pPr>
             <a:r>
-              <a:t>Blood cell: accuracy and loss</a:t>
+              <a:t>HAM10000: ROC and confusion matrices</a:t>
             </a:r>
           </a:p>
         </p:txBody>
       </p:sp>
       <p:pic>
         <p:nvPicPr>
-          <p:cNvPr id="3" name="Picture 2" descr="Blood_cell_accuracy.png"/>
+          <p:cNvPr id="3" name="Picture 2" descr="HAM10000_roc.png"/>
           <p:cNvPicPr>
             <a:picLocks noChangeAspect="1"/>
           </p:cNvPicPr>
@@ -3709,7 +3724,7 @@
         <p:spPr>
           <a:xfrm>
             <a:off x="502920" y="1051560"/>
-            <a:ext cx="5577840" cy="2244172"/>
+            <a:ext cx="5577840" cy="4395580"/>
           </a:xfrm>
           <a:prstGeom prst="rect">
             <a:avLst/>
@@ -3718,7 +3733,7 @@
       </p:pic>
       <p:pic>
         <p:nvPicPr>
-          <p:cNvPr id="4" name="Picture 3" descr="Blood_cell_loss.png"/>
+          <p:cNvPr id="4" name="Picture 3" descr="HAM10000_confusion.png"/>
           <p:cNvPicPr>
             <a:picLocks noChangeAspect="1"/>
           </p:cNvPicPr>
@@ -3733,49 +3748,13 @@
         <p:spPr>
           <a:xfrm>
             <a:off x="6217920" y="1051560"/>
-            <a:ext cx="5486400" cy="2207383"/>
+            <a:ext cx="5486400" cy="5481010"/>
           </a:xfrm>
           <a:prstGeom prst="rect">
             <a:avLst/>
           </a:prstGeom>
         </p:spPr>
       </p:pic>
-      <p:sp>
-        <p:nvSpPr>
-          <p:cNvPr id="5" name="TextBox 4"/>
-          <p:cNvSpPr txBox="1"/>
-          <p:nvPr/>
-        </p:nvSpPr>
-        <p:spPr>
-          <a:xfrm>
-            <a:off x="685800" y="4892040"/>
-            <a:ext cx="10881360" cy="1051560"/>
-          </a:xfrm>
-          <a:prstGeom prst="rect">
-            <a:avLst/>
-          </a:prstGeom>
-          <a:noFill/>
-        </p:spPr>
-        <p:txBody>
-          <a:bodyPr wrap="square">
-            <a:spAutoFit/>
-          </a:bodyPr>
-          <a:lstStyle/>
-          <a:p>
-            <a:pPr>
-              <a:defRPr sz="1700" b="0">
-                <a:solidFill>
-                  <a:srgbClr val="153B50"/>
-                </a:solidFill>
-                <a:latin typeface="Aptos"/>
-              </a:defRPr>
-            </a:pPr>
-            <a:r>
-              <a:t>Highest mean AUC: PCA, 0.630. The two charts show why accuracy and probability loss should be read together.</a:t>
-            </a:r>
-          </a:p>
-        </p:txBody>
-      </p:sp>
     </p:spTree>
   </p:cSld>
   <p:clrMapOvr>
@@ -3825,59 +3804,57 @@
               </a:defRPr>
             </a:pPr>
             <a:r>
-              <a:t>Blood cell: ROC and confusion matrices</a:t>
-            </a:r>
-          </a:p>
-        </p:txBody>
-      </p:sp>
-      <p:pic>
-        <p:nvPicPr>
-          <p:cNvPr id="3" name="Picture 2" descr="Blood_cell_roc.png"/>
-          <p:cNvPicPr>
-            <a:picLocks noChangeAspect="1"/>
-          </p:cNvPicPr>
-          <p:nvPr/>
-        </p:nvPicPr>
-        <p:blipFill>
-          <a:blip r:embed="rId2"/>
-          <a:stretch>
-            <a:fillRect/>
-          </a:stretch>
-        </p:blipFill>
-        <p:spPr>
-          <a:xfrm>
-            <a:off x="502920" y="1051560"/>
-            <a:ext cx="5577840" cy="4395580"/>
-          </a:xfrm>
-          <a:prstGeom prst="rect">
-            <a:avLst/>
-          </a:prstGeom>
-        </p:spPr>
-      </p:pic>
-      <p:pic>
-        <p:nvPicPr>
-          <p:cNvPr id="4" name="Picture 3" descr="Blood_cell_confusion.png"/>
-          <p:cNvPicPr>
-            <a:picLocks noChangeAspect="1"/>
-          </p:cNvPicPr>
-          <p:nvPr/>
-        </p:nvPicPr>
-        <p:blipFill>
-          <a:blip r:embed="rId3"/>
-          <a:stretch>
-            <a:fillRect/>
-          </a:stretch>
-        </p:blipFill>
-        <p:spPr>
-          <a:xfrm>
-            <a:off x="6217920" y="1051560"/>
-            <a:ext cx="5486400" cy="5481010"/>
-          </a:xfrm>
-          <a:prstGeom prst="rect">
-            <a:avLst/>
-          </a:prstGeom>
-        </p:spPr>
-      </p:pic>
+              <a:t>HAM10000: better ranking, weak positive precision</a:t>
+            </a:r>
+          </a:p>
+        </p:txBody>
+      </p:sp>
+      <p:sp>
+        <p:nvSpPr>
+          <p:cNvPr id="3" name="TextBox 2"/>
+          <p:cNvSpPr txBox="1"/>
+          <p:nvPr/>
+        </p:nvSpPr>
+        <p:spPr>
+          <a:xfrm>
+            <a:off x="731520" y="1234440"/>
+            <a:ext cx="10789920" cy="4846320"/>
+          </a:xfrm>
+          <a:prstGeom prst="rect">
+            <a:avLst/>
+          </a:prstGeom>
+          <a:noFill/>
+        </p:spPr>
+        <p:txBody>
+          <a:bodyPr wrap="square">
+            <a:spAutoFit/>
+          </a:bodyPr>
+          <a:lstStyle/>
+          <a:p>
+            <a:pPr>
+              <a:defRPr sz="2100" b="0">
+                <a:solidFill>
+                  <a:srgbClr val="153B50"/>
+                </a:solidFill>
+                <a:latin typeface="Aptos"/>
+              </a:defRPr>
+            </a:pPr>
+            <a:r>
+              <a:t>Isomap leads mean ROC AUC at 0.649, versus 0.602 for PCA. A neighbor graph may retain class-related structure that the largest-variance PCA axes miss. The experiment does not establish that mechanism.</a:t>
+            </a:r>
+            <a:br/>
+            <a:br/>
+            <a:r>
+              <a:t>PCA has slightly higher accuracy, 0.609 versus 0.590. AUC measures ranking across thresholds, while accuracy uses the prespecified 0.5 threshold.</a:t>
+            </a:r>
+            <a:br/>
+            <a:br/>
+            <a:r>
+              <a:t>Isomap precision is 0.134: most positive calls are false positives. The 8 × 8 pixels and low melanoma prevalence limit clinical meaning.</a:t>
+            </a:r>
+          </a:p>
+        </p:txBody>
+      </p:sp>
     </p:spTree>
   </p:cSld>
   <p:clrMapOvr>
@@ -3927,21 +3904,69 @@
               </a:defRPr>
             </a:pPr>
             <a:r>
-              <a:t>Blood cells: fast PCA wins on ranking</a:t>
-            </a:r>
-          </a:p>
-        </p:txBody>
-      </p:sp>
-      <p:sp>
-        <p:nvSpPr>
-          <p:cNvPr id="3" name="TextBox 2"/>
+              <a:t>Blood cell: accuracy and loss</a:t>
+            </a:r>
+          </a:p>
+        </p:txBody>
+      </p:sp>
+      <p:pic>
+        <p:nvPicPr>
+          <p:cNvPr id="3" name="Picture 2" descr="Blood_cell_accuracy.png"/>
+          <p:cNvPicPr>
+            <a:picLocks noChangeAspect="1"/>
+          </p:cNvPicPr>
+          <p:nvPr/>
+        </p:nvPicPr>
+        <p:blipFill>
+          <a:blip r:embed="rId2"/>
+          <a:stretch>
+            <a:fillRect/>
+          </a:stretch>
+        </p:blipFill>
+        <p:spPr>
+          <a:xfrm>
+            <a:off x="502920" y="1051560"/>
+            <a:ext cx="5577840" cy="2244172"/>
+          </a:xfrm>
+          <a:prstGeom prst="rect">
+            <a:avLst/>
+          </a:prstGeom>
+        </p:spPr>
+      </p:pic>
+      <p:pic>
+        <p:nvPicPr>
+          <p:cNvPr id="4" name="Picture 3" descr="Blood_cell_loss.png"/>
+          <p:cNvPicPr>
+            <a:picLocks noChangeAspect="1"/>
+          </p:cNvPicPr>
+          <p:nvPr/>
+        </p:nvPicPr>
+        <p:blipFill>
+          <a:blip r:embed="rId3"/>
+          <a:stretch>
+            <a:fillRect/>
+          </a:stretch>
+        </p:blipFill>
+        <p:spPr>
+          <a:xfrm>
+            <a:off x="6217920" y="1051560"/>
+            <a:ext cx="5486400" cy="2207383"/>
+          </a:xfrm>
+          <a:prstGeom prst="rect">
+            <a:avLst/>
+          </a:prstGeom>
+        </p:spPr>
+      </p:pic>
+      <p:sp>
+        <p:nvSpPr>
+          <p:cNvPr id="5" name="TextBox 4"/>
           <p:cNvSpPr txBox="1"/>
           <p:nvPr/>
         </p:nvSpPr>
         <p:spPr>
           <a:xfrm>
-            <a:off x="731520" y="1234440"/>
-            <a:ext cx="10789920" cy="4846320"/>
+            <a:off x="685800" y="4892040"/>
+            <a:ext cx="10881360" cy="1051560"/>
           </a:xfrm>
           <a:prstGeom prst="rect">
             <a:avLst/>
@@ -3955,7 +3980,7 @@
           <a:lstStyle/>
           <a:p>
             <a:pPr>
-              <a:defRPr sz="2100" b="0">
+              <a:defRPr sz="1700" b="0">
                 <a:solidFill>
                   <a:srgbClr val="153B50"/>
                 </a:solidFill>
@@ -3963,17 +3988,7 @@
               </a:defRPr>
             </a:pPr>
             <a:r>
-              <a:t>PCA leads mean ROC AUC at 0.630 and takes about 0.02 CPU seconds. Broad linear variation may capture useful signal in the 22 selected features.</a:t>
-            </a:r>
-            <a:br/>
-            <a:br/>
-            <a:r>
-              <a:t>SNE reaches 0.614 accuracy but only 0.581 AUC. Its threshold decisions look better than its overall ranking; accuracy alone would give a misleading winner.</a:t>
-            </a:r>
-            <a:br/>
-            <a:br/>
-            <a:r>
-              <a:t>MDS has 0.562 AUC and takes about 1.06 CPU seconds. Keeping global distances in two dimensions did not retain much class signal here. Patient-level generalization remains untested.</a:t>
+              <a:t>Highest mean AUC: PCA, 0.630. The two charts show why accuracy and probability loss should be read together.</a:t>
             </a:r>
           </a:p>
         </p:txBody>
@@ -4027,14 +4042,14 @@
               </a:defRPr>
             </a:pPr>
             <a:r>
-              <a:t>CPU time has a steep method cost</a:t>
+              <a:t>Blood cell: ROC and confusion matrices</a:t>
             </a:r>
           </a:p>
         </p:txBody>
       </p:sp>
       <p:pic>
         <p:nvPicPr>
-          <p:cNvPr id="3" name="Picture 2" descr="HAM10000_cpu.png"/>
+          <p:cNvPr id="3" name="Picture 2" descr="Blood_cell_roc.png"/>
           <p:cNvPicPr>
             <a:picLocks noChangeAspect="1"/>
           </p:cNvPicPr>
@@ -4049,7 +4064,7 @@
         <p:spPr>
           <a:xfrm>
             <a:off x="502920" y="1051560"/>
-            <a:ext cx="5577840" cy="2244172"/>
+            <a:ext cx="5577840" cy="4395580"/>
           </a:xfrm>
           <a:prstGeom prst="rect">
             <a:avLst/>
@@ -4058,7 +4073,7 @@
       </p:pic>
       <p:pic>
         <p:nvPicPr>
-          <p:cNvPr id="4" name="Picture 3" descr="Blood_cell_cpu.png"/>
+          <p:cNvPr id="4" name="Picture 3" descr="Blood_cell_confusion.png"/>
           <p:cNvPicPr>
             <a:picLocks noChangeAspect="1"/>
           </p:cNvPicPr>
@@ -4073,49 +4088,13 @@
         <p:spPr>
           <a:xfrm>
             <a:off x="6217920" y="1051560"/>
-            <a:ext cx="5486400" cy="2207383"/>
+            <a:ext cx="5486400" cy="5481010"/>
           </a:xfrm>
           <a:prstGeom prst="rect">
             <a:avLst/>
           </a:prstGeom>
         </p:spPr>
       </p:pic>
-      <p:sp>
-        <p:nvSpPr>
-          <p:cNvPr id="5" name="TextBox 4"/>
-          <p:cNvSpPr txBox="1"/>
-          <p:nvPr/>
-        </p:nvSpPr>
-        <p:spPr>
-          <a:xfrm>
-            <a:off x="685800" y="4892040"/>
-            <a:ext cx="10881360" cy="1051560"/>
-          </a:xfrm>
-          <a:prstGeom prst="rect">
-            <a:avLst/>
-          </a:prstGeom>
-          <a:noFill/>
-        </p:spPr>
-        <p:txBody>
-          <a:bodyPr wrap="square">
-            <a:spAutoFit/>
-          </a:bodyPr>
-          <a:lstStyle/>
-          <a:p>
-            <a:pPr>
-              <a:defRPr sz="1700" b="0">
-                <a:solidFill>
-                  <a:srgbClr val="153B50"/>
-                </a:solidFill>
-                <a:latin typeface="Aptos"/>
-              </a:defRPr>
-            </a:pPr>
-            <a:r>
-              <a:t>PCA and kernel PCA are fastest in this sample-size range. UMAP, SNE, and t-SNE require substantially more CPU time. UMAP's first compilation is measured separately.</a:t>
-            </a:r>
-          </a:p>
-        </p:txBody>
-      </p:sp>
     </p:spTree>
   </p:cSld>
   <p:clrMapOvr>
@@ -4165,7 +4144,7 @@
               </a:defRPr>
             </a:pPr>
             <a:r>
-              <a:t>CPU cost changes the practical choice</a:t>
+              <a:t>Blood cells: fast PCA wins on ranking</a:t>
             </a:r>
           </a:p>
         </p:txBody>
@@ -4201,17 +4180,17 @@
               </a:defRPr>
             </a:pPr>
             <a:r>
-              <a:t>On blood cells, PCA needs about 0.02 CPU seconds and SNE about 6.10 seconds per run. SNE does not gain AUC in exchange for that extra compute (0.581 versus 0.630).</a:t>
-            </a:r>
-            <a:br/>
-            <a:br/>
-            <a:r>
-              <a:t>On HAM10000, Isomap leads AUC at about 0.10 CPU seconds; UMAP is close in AUC (0.645 versus 0.649) but takes about 2.24 seconds.</a:t>
-            </a:r>
-            <a:br/>
-            <a:br/>
-            <a:r>
-              <a:t>These are process CPU times for 750 training and 300 test records. UMAP's one-time compilation warmup is excluded and recorded separately; scaling can change the order.</a:t>
+              <a:t>PCA leads mean ROC AUC at 0.630 and takes about 0.02 CPU seconds. Broad linear variation may capture useful signal in the 22 selected features.</a:t>
+            </a:r>
+            <a:br/>
+            <a:br/>
+            <a:r>
+              <a:t>SNE reaches 0.614 accuracy but only 0.581 AUC. Its threshold decisions look better than its overall ranking; accuracy alone would give a misleading winner.</a:t>
+            </a:r>
+            <a:br/>
+            <a:br/>
+            <a:r>
+              <a:t>MDS has 0.562 AUC and takes about 1.06 CPU seconds. Keeping global distances in two dimensions did not retain much class signal here. Patient-level generalization remains untested.</a:t>
             </a:r>
           </a:p>
         </p:txBody>
@@ -4265,14 +4244,14 @@
               </a:defRPr>
             </a:pPr>
             <a:r>
-              <a:t>Parameter settings change the ranking</a:t>
+              <a:t>CPU time has a steep method cost</a:t>
             </a:r>
           </a:p>
         </p:txBody>
       </p:sp>
       <p:pic>
         <p:nvPicPr>
-          <p:cNvPr id="3" name="Picture 2" descr="HAM10000_parameters.png"/>
+          <p:cNvPr id="3" name="Picture 2" descr="HAM10000_cpu.png"/>
           <p:cNvPicPr>
             <a:picLocks noChangeAspect="1"/>
           </p:cNvPicPr>
@@ -4287,7 +4266,7 @@
         <p:spPr>
           <a:xfrm>
             <a:off x="502920" y="1051560"/>
-            <a:ext cx="5577840" cy="2919130"/>
+            <a:ext cx="5577840" cy="2244172"/>
           </a:xfrm>
           <a:prstGeom prst="rect">
             <a:avLst/>
@@ -4296,7 +4275,7 @@
       </p:pic>
       <p:pic>
         <p:nvPicPr>
-          <p:cNvPr id="4" name="Picture 3" descr="Blood_cell_parameters.png"/>
+          <p:cNvPr id="4" name="Picture 3" descr="Blood_cell_cpu.png"/>
           <p:cNvPicPr>
             <a:picLocks noChangeAspect="1"/>
           </p:cNvPicPr>
@@ -4311,7 +4290,7 @@
         <p:spPr>
           <a:xfrm>
             <a:off x="6217920" y="1051560"/>
-            <a:ext cx="5486400" cy="2871275"/>
+            <a:ext cx="5486400" cy="2207383"/>
           </a:xfrm>
           <a:prstGeom prst="rect">
             <a:avLst/>
@@ -4349,7 +4328,7 @@
               </a:defRPr>
             </a:pPr>
             <a:r>
-              <a:t>A second setting changes neighborhood size or perplexity. Selecting a winner on the test set would inflate the reported result.</a:t>
+              <a:t>PCA and kernel PCA are fastest in this sample-size range. UMAP, SNE, and t-SNE require substantially more CPU time. UMAP's first compilation is measured separately.</a:t>
             </a:r>
           </a:p>
         </p:txBody>
@@ -4503,7 +4482,7 @@
               </a:defRPr>
             </a:pPr>
             <a:r>
-              <a:t>What the parameter comparison can and cannot say</a:t>
+              <a:t>CPU cost changes the practical choice</a:t>
             </a:r>
           </a:p>
         </p:txBody>
@@ -4539,17 +4518,17 @@
               </a:defRPr>
             </a:pPr>
             <a:r>
-              <a:t>Setting A was declared primary before reading test results. Setting B checks whether whitening, kernel scale, perplexity, neighbor count, MDS iterations, or PCoA distance changes the result.</a:t>
-            </a:r>
-            <a:br/>
-            <a:br/>
-            <a:r>
-              <a:t>Large A-to-B shifts show tuning sensitivity, especially for methods that define neighborhoods. They do not justify choosing the better test-set setting after the fact.</a:t>
-            </a:r>
-            <a:br/>
-            <a:br/>
-            <a:r>
-              <a:t>A stronger study would tune parameters inside each training fold and then evaluate once on an untouched outer test fold.</a:t>
+              <a:t>On blood cells, PCA needs about 0.02 CPU seconds and SNE about 6.10 seconds per run. SNE does not gain AUC in exchange for that extra compute (0.581 versus 0.630).</a:t>
+            </a:r>
+            <a:br/>
+            <a:br/>
+            <a:r>
+              <a:t>On HAM10000, Isomap leads AUC at about 0.10 CPU seconds; UMAP is close in AUC (0.645 versus 0.649) but takes about 2.24 seconds.</a:t>
+            </a:r>
+            <a:br/>
+            <a:br/>
+            <a:r>
+              <a:t>These are process CPU times for 750 training and 300 test records. UMAP's one-time compilation warmup is excluded and recorded separately; scaling can change the order.</a:t>
             </a:r>
           </a:p>
         </p:txBody>
@@ -4603,14 +4582,14 @@
               </a:defRPr>
             </a:pPr>
             <a:r>
-              <a:t>Gaussian SNE optimization loss</a:t>
+              <a:t>Parameter settings change the ranking</a:t>
             </a:r>
           </a:p>
         </p:txBody>
       </p:sp>
       <p:pic>
         <p:nvPicPr>
-          <p:cNvPr id="3" name="Picture 2" descr="sne_objective.png"/>
+          <p:cNvPr id="3" name="Picture 2" descr="HAM10000_parameters.png"/>
           <p:cNvPicPr>
             <a:picLocks noChangeAspect="1"/>
           </p:cNvPicPr>
@@ -4624,24 +4603,48 @@
         </p:blipFill>
         <p:spPr>
           <a:xfrm>
-            <a:off x="594360" y="1097280"/>
-            <a:ext cx="7315200" cy="2717554"/>
+            <a:off x="502920" y="1051560"/>
+            <a:ext cx="5577840" cy="2919130"/>
           </a:xfrm>
           <a:prstGeom prst="rect">
             <a:avLst/>
           </a:prstGeom>
         </p:spPr>
       </p:pic>
-      <p:sp>
-        <p:nvSpPr>
-          <p:cNvPr id="4" name="TextBox 3"/>
+      <p:pic>
+        <p:nvPicPr>
+          <p:cNvPr id="4" name="Picture 3" descr="Blood_cell_parameters.png"/>
+          <p:cNvPicPr>
+            <a:picLocks noChangeAspect="1"/>
+          </p:cNvPicPr>
+          <p:nvPr/>
+        </p:nvPicPr>
+        <p:blipFill>
+          <a:blip r:embed="rId3"/>
+          <a:stretch>
+            <a:fillRect/>
+          </a:stretch>
+        </p:blipFill>
+        <p:spPr>
+          <a:xfrm>
+            <a:off x="6217920" y="1051560"/>
+            <a:ext cx="5486400" cy="2871275"/>
+          </a:xfrm>
+          <a:prstGeom prst="rect">
+            <a:avLst/>
+          </a:prstGeom>
+        </p:spPr>
+      </p:pic>
+      <p:sp>
+        <p:nvSpPr>
+          <p:cNvPr id="5" name="TextBox 4"/>
           <p:cNvSpPr txBox="1"/>
           <p:nvPr/>
         </p:nvSpPr>
         <p:spPr>
           <a:xfrm>
-            <a:off x="8092440" y="1325880"/>
-            <a:ext cx="3520440" cy="4480560"/>
+            <a:off x="685800" y="4892040"/>
+            <a:ext cx="10881360" cy="1051560"/>
           </a:xfrm>
           <a:prstGeom prst="rect">
             <a:avLst/>
@@ -4655,7 +4658,7 @@
           <a:lstStyle/>
           <a:p>
             <a:pPr>
-              <a:defRPr sz="1800" b="0">
+              <a:defRPr sz="1700" b="0">
                 <a:solidFill>
                   <a:srgbClr val="153B50"/>
                 </a:solidFill>
@@ -4663,7 +4666,7 @@
               </a:defRPr>
             </a:pPr>
             <a:r>
-              <a:t>The plotted KL objective tracks Gaussian SNE fitting. Native PCA, t-SNE, and UMAP objectives have different meanings. The earlier classifier log-loss charts are comparable across methods.</a:t>
+              <a:t>A second setting changes neighborhood size or perplexity. Selecting a winner on the test set would inflate the reported result.</a:t>
             </a:r>
           </a:p>
         </p:txBody>
@@ -4717,45 +4720,21 @@
               </a:defRPr>
             </a:pPr>
             <a:r>
-              <a:t>FROC AUC is not available</a:t>
-            </a:r>
-          </a:p>
-        </p:txBody>
-      </p:sp>
-      <p:pic>
-        <p:nvPicPr>
-          <p:cNvPr id="3" name="Picture 2" descr="froc_applicability.png"/>
-          <p:cNvPicPr>
-            <a:picLocks noChangeAspect="1"/>
-          </p:cNvPicPr>
-          <p:nvPr/>
-        </p:nvPicPr>
-        <p:blipFill>
-          <a:blip r:embed="rId2"/>
-          <a:stretch>
-            <a:fillRect/>
-          </a:stretch>
-        </p:blipFill>
-        <p:spPr>
-          <a:xfrm>
-            <a:off x="594360" y="1097280"/>
-            <a:ext cx="7315200" cy="2817280"/>
-          </a:xfrm>
-          <a:prstGeom prst="rect">
-            <a:avLst/>
-          </a:prstGeom>
-        </p:spPr>
-      </p:pic>
-      <p:sp>
-        <p:nvSpPr>
-          <p:cNvPr id="4" name="TextBox 3"/>
+              <a:t>What the parameter comparison can and cannot say</a:t>
+            </a:r>
+          </a:p>
+        </p:txBody>
+      </p:sp>
+      <p:sp>
+        <p:nvSpPr>
+          <p:cNvPr id="3" name="TextBox 2"/>
           <p:cNvSpPr txBox="1"/>
           <p:nvPr/>
         </p:nvSpPr>
         <p:spPr>
           <a:xfrm>
-            <a:off x="8092440" y="1325880"/>
-            <a:ext cx="3520440" cy="4480560"/>
+            <a:off x="731520" y="1234440"/>
+            <a:ext cx="10789920" cy="4846320"/>
           </a:xfrm>
           <a:prstGeom prst="rect">
             <a:avLst/>
@@ -4769,7 +4748,7 @@
           <a:lstStyle/>
           <a:p>
             <a:pPr>
-              <a:defRPr sz="1800" b="0">
+              <a:defRPr sz="2100" b="0">
                 <a:solidFill>
                   <a:srgbClr val="153B50"/>
                 </a:solidFill>
@@ -4777,7 +4756,17 @@
               </a:defRPr>
             </a:pPr>
             <a:r>
-              <a:t>ROC AUC is reported. A valid FROC needs scored candidate lesion locations and false positives per image. These tables have one label and one score per record.</a:t>
+              <a:t>Setting A was declared primary before reading test results. Setting B checks whether whitening, kernel scale, perplexity, neighbor count, MDS iterations, or PCoA distance changes the result.</a:t>
+            </a:r>
+            <a:br/>
+            <a:br/>
+            <a:r>
+              <a:t>Large A-to-B shifts show tuning sensitivity, especially for methods that define neighborhoods. They do not justify choosing the better test-set setting after the fact.</a:t>
+            </a:r>
+            <a:br/>
+            <a:br/>
+            <a:r>
+              <a:t>A stronger study would tune parameters inside each training fold and then evaluate once on an untouched outer test fold.</a:t>
             </a:r>
           </a:p>
         </p:txBody>
@@ -4831,21 +4820,45 @@
               </a:defRPr>
             </a:pPr>
             <a:r>
-              <a:t>Statistical tests are exploratory</a:t>
-            </a:r>
-          </a:p>
-        </p:txBody>
-      </p:sp>
-      <p:sp>
-        <p:nvSpPr>
-          <p:cNvPr id="3" name="TextBox 2"/>
+              <a:t>Gaussian SNE optimization loss</a:t>
+            </a:r>
+          </a:p>
+        </p:txBody>
+      </p:sp>
+      <p:pic>
+        <p:nvPicPr>
+          <p:cNvPr id="3" name="Picture 2" descr="sne_objective.png"/>
+          <p:cNvPicPr>
+            <a:picLocks noChangeAspect="1"/>
+          </p:cNvPicPr>
+          <p:nvPr/>
+        </p:nvPicPr>
+        <p:blipFill>
+          <a:blip r:embed="rId2"/>
+          <a:stretch>
+            <a:fillRect/>
+          </a:stretch>
+        </p:blipFill>
+        <p:spPr>
+          <a:xfrm>
+            <a:off x="594360" y="1097280"/>
+            <a:ext cx="7315200" cy="2717554"/>
+          </a:xfrm>
+          <a:prstGeom prst="rect">
+            <a:avLst/>
+          </a:prstGeom>
+        </p:spPr>
+      </p:pic>
+      <p:sp>
+        <p:nvSpPr>
+          <p:cNvPr id="4" name="TextBox 3"/>
           <p:cNvSpPr txBox="1"/>
           <p:nvPr/>
         </p:nvSpPr>
         <p:spPr>
           <a:xfrm>
-            <a:off x="731520" y="1234440"/>
-            <a:ext cx="10789920" cy="4846320"/>
+            <a:off x="8092440" y="1325880"/>
+            <a:ext cx="3520440" cy="4480560"/>
           </a:xfrm>
           <a:prstGeom prst="rect">
             <a:avLst/>
@@ -4859,7 +4872,7 @@
           <a:lstStyle/>
           <a:p>
             <a:pPr>
-              <a:defRPr sz="2100" b="0">
+              <a:defRPr sz="1800" b="0">
                 <a:solidFill>
                   <a:srgbClr val="153B50"/>
                 </a:solidFill>
@@ -4867,12 +4880,7 @@
               </a:defRPr>
             </a:pPr>
             <a:r>
-              <a:t>Repeated-measures ANOVA of AUC: F(8,40)=0.673, p=0.712. Descriptive MANOVA method term: Wilks' lambda=0.840, p=0.945.</a:t>
-            </a:r>
-            <a:br/>
-            <a:br/>
-            <a:r>
-              <a:t>Paired t, Wilcoxon, and McNemar z comparisons are in the repository. Three overlapping splits have low power. MANOVA's independence assumption is violated. Read all p values as diagnostics.</a:t>
+              <a:t>The plotted KL objective tracks Gaussian SNE fitting. Native PCA, t-SNE, and UMAP objectives have different meanings. The earlier classifier log-loss charts are comparable across methods.</a:t>
             </a:r>
           </a:p>
         </p:txBody>
@@ -4926,21 +4934,45 @@
               </a:defRPr>
             </a:pPr>
             <a:r>
-              <a:t>What counts as good or bad evidence here</a:t>
-            </a:r>
-          </a:p>
-        </p:txBody>
-      </p:sp>
-      <p:sp>
-        <p:nvSpPr>
-          <p:cNvPr id="3" name="TextBox 2"/>
+              <a:t>FROC AUC is not available</a:t>
+            </a:r>
+          </a:p>
+        </p:txBody>
+      </p:sp>
+      <p:pic>
+        <p:nvPicPr>
+          <p:cNvPr id="3" name="Picture 2" descr="froc_applicability.png"/>
+          <p:cNvPicPr>
+            <a:picLocks noChangeAspect="1"/>
+          </p:cNvPicPr>
+          <p:nvPr/>
+        </p:nvPicPr>
+        <p:blipFill>
+          <a:blip r:embed="rId2"/>
+          <a:stretch>
+            <a:fillRect/>
+          </a:stretch>
+        </p:blipFill>
+        <p:spPr>
+          <a:xfrm>
+            <a:off x="594360" y="1097280"/>
+            <a:ext cx="7315200" cy="2817280"/>
+          </a:xfrm>
+          <a:prstGeom prst="rect">
+            <a:avLst/>
+          </a:prstGeom>
+        </p:spPr>
+      </p:pic>
+      <p:sp>
+        <p:nvSpPr>
+          <p:cNvPr id="4" name="TextBox 3"/>
           <p:cNvSpPr txBox="1"/>
           <p:nvPr/>
         </p:nvSpPr>
         <p:spPr>
           <a:xfrm>
-            <a:off x="731520" y="1234440"/>
-            <a:ext cx="10789920" cy="4846320"/>
+            <a:off x="8092440" y="1325880"/>
+            <a:ext cx="3520440" cy="4480560"/>
           </a:xfrm>
           <a:prstGeom prst="rect">
             <a:avLst/>
@@ -4954,7 +4986,7 @@
           <a:lstStyle/>
           <a:p>
             <a:pPr>
-              <a:defRPr sz="2100" b="0">
+              <a:defRPr sz="1800" b="0">
                 <a:solidFill>
                   <a:srgbClr val="153B50"/>
                 </a:solidFill>
@@ -4962,17 +4994,7 @@
               </a:defRPr>
             </a:pPr>
             <a:r>
-              <a:t>A good result would combine high held-out AUC with useful sensitivity and precision, low log loss, stable parameters, and an acceptable CPU cost. None of these pilot AUCs exceeds 0.65.</a:t>
-            </a:r>
-            <a:br/>
-            <a:br/>
-            <a:r>
-              <a:t>A method can look good on one metric and weak on another: SNE has the highest blood-cell accuracy but lower AUC than PCA; Isomap leads HAM AUC but its positive precision is only 0.134.</a:t>
-            </a:r>
-            <a:br/>
-            <a:br/>
-            <a:r>
-              <a:t>Three overlapping splits do not provide a reliable superiority claim. The statistical tests and plots describe this experiment, not clinical readiness.</a:t>
+              <a:t>ROC AUC is reported. A valid FROC needs scored candidate lesion locations and false positives per image. These tables have one label and one score per record.</a:t>
             </a:r>
           </a:p>
         </p:txBody>
@@ -5026,7 +5048,7 @@
               </a:defRPr>
             </a:pPr>
             <a:r>
-              <a:t>Interpretation and next steps</a:t>
+              <a:t>Statistical tests are exploratory</a:t>
             </a:r>
           </a:p>
         </p:txBody>
@@ -5062,26 +5084,44 @@
               </a:defRPr>
             </a:pPr>
             <a:r>
-              <a:t>Performance changes with split and parameter choice. The 8 × 8 lesion images limit clinical meaning. The blood-cell table lacks patient-level validation.</a:t>
-            </a:r>
-            <a:br/>
-            <a:br/>
-            <a:r>
-              <a:t>For a journal study: use original or validated features, external cohorts, nested tuning, uncertainty intervals, and lesion locations if FROC is required.</a:t>
-            </a:r>
-          </a:p>
-        </p:txBody>
-      </p:sp>
-      <p:sp>
-        <p:nvSpPr>
-          <p:cNvPr id="4" name="TextBox 3"/>
+              <a:t>Repeated-measures ANOVA of AUC: F(8,40)=0.673, p=0.712. Descriptive MANOVA method term: Wilks' lambda=0.840, p=0.945.</a:t>
+            </a:r>
+            <a:br/>
+            <a:br/>
+            <a:r>
+              <a:t>Paired t, Wilcoxon, and McNemar z comparisons are in the repository. Three overlapping splits have low power. MANOVA's independence assumption is violated. Read all p values as diagnostics.</a:t>
+            </a:r>
+          </a:p>
+        </p:txBody>
+      </p:sp>
+    </p:spTree>
+  </p:cSld>
+  <p:clrMapOvr>
+    <a:masterClrMapping/>
+  </p:clrMapOvr>
+</p:sld>
+</file>
+
+<file path=ppt/slides/slide26.xml><?xml version="1.0" encoding="utf-8"?>
+<p:sld xmlns:a="http://schemas.openxmlformats.org/drawingml/2006/main" xmlns:p="http://schemas.openxmlformats.org/presentationml/2006/main" xmlns:r="http://schemas.openxmlformats.org/officeDocument/2006/relationships">
+  <p:cSld>
+    <p:spTree>
+      <p:nvGrpSpPr>
+        <p:cNvPr id="1" name=""/>
+        <p:cNvGrpSpPr/>
+        <p:nvPr/>
+      </p:nvGrpSpPr>
+      <p:grpSpPr/>
+      <p:sp>
+        <p:nvSpPr>
+          <p:cNvPr id="2" name="TextBox 1"/>
           <p:cNvSpPr txBox="1"/>
           <p:nvPr/>
         </p:nvSpPr>
         <p:spPr>
           <a:xfrm>
-            <a:off x="594360" y="6446520"/>
-            <a:ext cx="10972800" cy="274320"/>
+            <a:off x="502920" y="228600"/>
+            <a:ext cx="10972800" cy="640080"/>
           </a:xfrm>
           <a:prstGeom prst="rect">
             <a:avLst/>
@@ -5095,7 +5135,308 @@
           <a:lstStyle/>
           <a:p>
             <a:pPr>
-              <a:defRPr sz="1000" b="0">
+              <a:defRPr sz="2900" b="1">
+                <a:solidFill>
+                  <a:srgbClr val="153B50"/>
+                </a:solidFill>
+                <a:latin typeface="Aptos"/>
+              </a:defRPr>
+            </a:pPr>
+            <a:r>
+              <a:t>What counts as good or bad evidence here</a:t>
+            </a:r>
+          </a:p>
+        </p:txBody>
+      </p:sp>
+      <p:sp>
+        <p:nvSpPr>
+          <p:cNvPr id="3" name="TextBox 2"/>
+          <p:cNvSpPr txBox="1"/>
+          <p:nvPr/>
+        </p:nvSpPr>
+        <p:spPr>
+          <a:xfrm>
+            <a:off x="731520" y="1234440"/>
+            <a:ext cx="10789920" cy="4846320"/>
+          </a:xfrm>
+          <a:prstGeom prst="rect">
+            <a:avLst/>
+          </a:prstGeom>
+          <a:noFill/>
+        </p:spPr>
+        <p:txBody>
+          <a:bodyPr wrap="square">
+            <a:spAutoFit/>
+          </a:bodyPr>
+          <a:lstStyle/>
+          <a:p>
+            <a:pPr>
+              <a:defRPr sz="2100" b="0">
+                <a:solidFill>
+                  <a:srgbClr val="153B50"/>
+                </a:solidFill>
+                <a:latin typeface="Aptos"/>
+              </a:defRPr>
+            </a:pPr>
+            <a:r>
+              <a:t>A good result would combine high held-out AUC with useful sensitivity and precision, low log loss, stable parameters, and an acceptable CPU cost. None of these pilot AUCs exceeds 0.65.</a:t>
+            </a:r>
+            <a:br/>
+            <a:br/>
+            <a:r>
+              <a:t>A method can look good on one metric and weak on another: SNE has the highest blood-cell accuracy but lower AUC than PCA; Isomap leads HAM AUC but its positive precision is only 0.134.</a:t>
+            </a:r>
+            <a:br/>
+            <a:br/>
+            <a:r>
+              <a:t>Three overlapping splits do not provide a reliable superiority claim. The statistical tests and plots describe this experiment, not clinical readiness.</a:t>
+            </a:r>
+          </a:p>
+        </p:txBody>
+      </p:sp>
+    </p:spTree>
+  </p:cSld>
+  <p:clrMapOvr>
+    <a:masterClrMapping/>
+  </p:clrMapOvr>
+</p:sld>
+</file>
+
+<file path=ppt/slides/slide27.xml><?xml version="1.0" encoding="utf-8"?>
+<p:sld xmlns:a="http://schemas.openxmlformats.org/drawingml/2006/main" xmlns:p="http://schemas.openxmlformats.org/presentationml/2006/main" xmlns:r="http://schemas.openxmlformats.org/officeDocument/2006/relationships">
+  <p:cSld>
+    <p:spTree>
+      <p:nvGrpSpPr>
+        <p:cNvPr id="1" name=""/>
+        <p:cNvGrpSpPr/>
+        <p:nvPr/>
+      </p:nvGrpSpPr>
+      <p:grpSpPr/>
+      <p:sp>
+        <p:nvSpPr>
+          <p:cNvPr id="2" name="TextBox 1"/>
+          <p:cNvSpPr txBox="1"/>
+          <p:nvPr/>
+        </p:nvSpPr>
+        <p:spPr>
+          <a:xfrm>
+            <a:off x="502920" y="228600"/>
+            <a:ext cx="10972800" cy="640080"/>
+          </a:xfrm>
+          <a:prstGeom prst="rect">
+            <a:avLst/>
+          </a:prstGeom>
+          <a:noFill/>
+        </p:spPr>
+        <p:txBody>
+          <a:bodyPr wrap="square">
+            <a:spAutoFit/>
+          </a:bodyPr>
+          <a:lstStyle/>
+          <a:p>
+            <a:pPr>
+              <a:defRPr sz="2900" b="1">
+                <a:solidFill>
+                  <a:srgbClr val="153B50"/>
+                </a:solidFill>
+                <a:latin typeface="Aptos"/>
+              </a:defRPr>
+            </a:pPr>
+            <a:r>
+              <a:t>Notebook extension: eleven methods</a:t>
+            </a:r>
+          </a:p>
+        </p:txBody>
+      </p:sp>
+      <p:sp>
+        <p:nvSpPr>
+          <p:cNvPr id="3" name="TextBox 2"/>
+          <p:cNvSpPr txBox="1"/>
+          <p:nvPr/>
+        </p:nvSpPr>
+        <p:spPr>
+          <a:xfrm>
+            <a:off x="731520" y="1234440"/>
+            <a:ext cx="10789920" cy="4846320"/>
+          </a:xfrm>
+          <a:prstGeom prst="rect">
+            <a:avLst/>
+          </a:prstGeom>
+          <a:noFill/>
+        </p:spPr>
+        <p:txBody>
+          <a:bodyPr wrap="square">
+            <a:spAutoFit/>
+          </a:bodyPr>
+          <a:lstStyle/>
+          <a:p>
+            <a:pPr>
+              <a:defRPr sz="2100" b="0">
+                <a:solidFill>
+                  <a:srgbClr val="153B50"/>
+                </a:solidFill>
+                <a:latin typeface="Aptos"/>
+              </a:defRPr>
+            </a:pPr>
+            <a:r>
+              <a:t>The full Kaggle notebook adds locally linear embedding (LLE) and an exploratory PCA + UMAP hybrid to the original nine methods. It applies the same two settings, three seeds, held-out classifier, and metrics.</a:t>
+            </a:r>
+            <a:br/>
+            <a:br/>
+            <a:r>
+              <a:t>LLE reconstructs local neighborhoods from weighted neighbors. PCA + UMAP first reduces the feature space to at most 30 PCA coordinates, then builds the UMAP neighbor graph. Both are unsupervised two-dimensional representations.</a:t>
+            </a:r>
+            <a:br/>
+            <a:br/>
+            <a:r>
+              <a:t>Across three splits, HAM AUC is 0.648 for PCA + UMAP versus 0.649 for Isomap. Blood-cell AUC is 0.632 for PCA + UMAP versus 0.630 for PCA. These tiny differences do not establish superiority, and the hybrid costs more CPU time.</a:t>
+            </a:r>
+          </a:p>
+        </p:txBody>
+      </p:sp>
+    </p:spTree>
+  </p:cSld>
+  <p:clrMapOvr>
+    <a:masterClrMapping/>
+  </p:clrMapOvr>
+</p:sld>
+</file>
+
+<file path=ppt/slides/slide28.xml><?xml version="1.0" encoding="utf-8"?>
+<p:sld xmlns:a="http://schemas.openxmlformats.org/drawingml/2006/main" xmlns:p="http://schemas.openxmlformats.org/presentationml/2006/main" xmlns:r="http://schemas.openxmlformats.org/officeDocument/2006/relationships">
+  <p:cSld>
+    <p:spTree>
+      <p:nvGrpSpPr>
+        <p:cNvPr id="1" name=""/>
+        <p:cNvGrpSpPr/>
+        <p:nvPr/>
+      </p:nvGrpSpPr>
+      <p:grpSpPr/>
+      <p:sp>
+        <p:nvSpPr>
+          <p:cNvPr id="2" name="TextBox 1"/>
+          <p:cNvSpPr txBox="1"/>
+          <p:nvPr/>
+        </p:nvSpPr>
+        <p:spPr>
+          <a:xfrm>
+            <a:off x="594360" y="320040"/>
+            <a:ext cx="10972800" cy="594360"/>
+          </a:xfrm>
+          <a:prstGeom prst="rect">
+            <a:avLst/>
+          </a:prstGeom>
+          <a:noFill/>
+        </p:spPr>
+        <p:txBody>
+          <a:bodyPr wrap="square">
+            <a:spAutoFit/>
+          </a:bodyPr>
+          <a:lstStyle/>
+          <a:p>
+            <a:pPr>
+              <a:defRPr sz="2800" b="1">
+                <a:solidFill>
+                  <a:srgbClr val="153B50"/>
+                </a:solidFill>
+                <a:latin typeface="Aptos"/>
+              </a:defRPr>
+            </a:pPr>
+            <a:r>
+              <a:t>HAM10000: class maps remain mixed</a:t>
+            </a:r>
+          </a:p>
+        </p:txBody>
+      </p:sp>
+      <p:pic>
+        <p:nvPicPr>
+          <p:cNvPr id="3" name="Picture 2" descr="HAM10000_focus_classes.png"/>
+          <p:cNvPicPr>
+            <a:picLocks noChangeAspect="1"/>
+          </p:cNvPicPr>
+          <p:nvPr/>
+        </p:nvPicPr>
+        <p:blipFill>
+          <a:blip r:embed="rId2"/>
+          <a:stretch>
+            <a:fillRect/>
+          </a:stretch>
+        </p:blipFill>
+        <p:spPr>
+          <a:xfrm>
+            <a:off x="502920" y="1024128"/>
+            <a:ext cx="7955279" cy="5208106"/>
+          </a:xfrm>
+          <a:prstGeom prst="rect">
+            <a:avLst/>
+          </a:prstGeom>
+        </p:spPr>
+      </p:pic>
+      <p:sp>
+        <p:nvSpPr>
+          <p:cNvPr id="4" name="TextBox 3"/>
+          <p:cNvSpPr txBox="1"/>
+          <p:nvPr/>
+        </p:nvSpPr>
+        <p:spPr>
+          <a:xfrm>
+            <a:off x="8686800" y="1325880"/>
+            <a:ext cx="2926080" cy="4663440"/>
+          </a:xfrm>
+          <a:prstGeom prst="rect">
+            <a:avLst/>
+          </a:prstGeom>
+          <a:noFill/>
+        </p:spPr>
+        <p:txBody>
+          <a:bodyPr wrap="square">
+            <a:spAutoFit/>
+          </a:bodyPr>
+          <a:lstStyle/>
+          <a:p>
+            <a:pPr>
+              <a:defRPr sz="1700" b="0">
+                <a:solidFill>
+                  <a:srgbClr val="153B50"/>
+                </a:solidFill>
+                <a:latin typeface="Aptos"/>
+              </a:defRPr>
+            </a:pPr>
+            <a:r>
+              <a:t>Orange melanoma points overlap blue non-melanoma points in every map. Isomap and PCA + UMAP curve the geometry, but neither creates a clean class boundary.</a:t>
+            </a:r>
+            <a:br/>
+            <a:br/>
+            <a:r>
+              <a:t>This first split has lower AUC than the three-split mean for several methods. The change across splits is evidence of instability. Visual separation alone cannot select a winner.</a:t>
+            </a:r>
+          </a:p>
+        </p:txBody>
+      </p:sp>
+      <p:sp>
+        <p:nvSpPr>
+          <p:cNvPr id="5" name="TextBox 4"/>
+          <p:cNvSpPr txBox="1"/>
+          <p:nvPr/>
+        </p:nvSpPr>
+        <p:spPr>
+          <a:xfrm>
+            <a:off x="594360" y="6473952"/>
+            <a:ext cx="10972800" cy="201168"/>
+          </a:xfrm>
+          <a:prstGeom prst="rect">
+            <a:avLst/>
+          </a:prstGeom>
+          <a:noFill/>
+        </p:spPr>
+        <p:txBody>
+          <a:bodyPr wrap="square">
+            <a:spAutoFit/>
+          </a:bodyPr>
+          <a:lstStyle/>
+          <a:p>
+            <a:pPr>
+              <a:defRPr sz="900" b="0">
                 <a:solidFill>
                   <a:srgbClr val="5C6770"/>
                 </a:solidFill>
@@ -5103,7 +5444,162 @@
               </a:defRPr>
             </a:pPr>
             <a:r>
-              <a:t>Sources and exact numbers: AML_research_report.docx and results/primary_summary.csv</a:t>
+              <a:t>Notebook extension: setting A, first split shown; AUC beside each map is for that split only.</a:t>
+            </a:r>
+          </a:p>
+        </p:txBody>
+      </p:sp>
+    </p:spTree>
+  </p:cSld>
+  <p:clrMapOvr>
+    <a:masterClrMapping/>
+  </p:clrMapOvr>
+</p:sld>
+</file>
+
+<file path=ppt/slides/slide29.xml><?xml version="1.0" encoding="utf-8"?>
+<p:sld xmlns:a="http://schemas.openxmlformats.org/drawingml/2006/main" xmlns:p="http://schemas.openxmlformats.org/presentationml/2006/main" xmlns:r="http://schemas.openxmlformats.org/officeDocument/2006/relationships">
+  <p:cSld>
+    <p:spTree>
+      <p:nvGrpSpPr>
+        <p:cNvPr id="1" name=""/>
+        <p:cNvGrpSpPr/>
+        <p:nvPr/>
+      </p:nvGrpSpPr>
+      <p:grpSpPr/>
+      <p:sp>
+        <p:nvSpPr>
+          <p:cNvPr id="2" name="TextBox 1"/>
+          <p:cNvSpPr txBox="1"/>
+          <p:nvPr/>
+        </p:nvSpPr>
+        <p:spPr>
+          <a:xfrm>
+            <a:off x="594360" y="320040"/>
+            <a:ext cx="10972800" cy="594360"/>
+          </a:xfrm>
+          <a:prstGeom prst="rect">
+            <a:avLst/>
+          </a:prstGeom>
+          <a:noFill/>
+        </p:spPr>
+        <p:txBody>
+          <a:bodyPr wrap="square">
+            <a:spAutoFit/>
+          </a:bodyPr>
+          <a:lstStyle/>
+          <a:p>
+            <a:pPr>
+              <a:defRPr sz="2800" b="1">
+                <a:solidFill>
+                  <a:srgbClr val="153B50"/>
+                </a:solidFill>
+                <a:latin typeface="Aptos"/>
+              </a:defRPr>
+            </a:pPr>
+            <a:r>
+              <a:t>Blood cells: clusters are not class labels</a:t>
+            </a:r>
+          </a:p>
+        </p:txBody>
+      </p:sp>
+      <p:pic>
+        <p:nvPicPr>
+          <p:cNvPr id="3" name="Picture 2" descr="Blood_cell_focus_classes.png"/>
+          <p:cNvPicPr>
+            <a:picLocks noChangeAspect="1"/>
+          </p:cNvPicPr>
+          <p:nvPr/>
+        </p:nvPicPr>
+        <p:blipFill>
+          <a:blip r:embed="rId2"/>
+          <a:stretch>
+            <a:fillRect/>
+          </a:stretch>
+        </p:blipFill>
+        <p:spPr>
+          <a:xfrm>
+            <a:off x="502920" y="1024128"/>
+            <a:ext cx="7955279" cy="5208106"/>
+          </a:xfrm>
+          <a:prstGeom prst="rect">
+            <a:avLst/>
+          </a:prstGeom>
+        </p:spPr>
+      </p:pic>
+      <p:sp>
+        <p:nvSpPr>
+          <p:cNvPr id="4" name="TextBox 3"/>
+          <p:cNvSpPr txBox="1"/>
+          <p:nvPr/>
+        </p:nvSpPr>
+        <p:spPr>
+          <a:xfrm>
+            <a:off x="8686800" y="1325880"/>
+            <a:ext cx="2926080" cy="4663440"/>
+          </a:xfrm>
+          <a:prstGeom prst="rect">
+            <a:avLst/>
+          </a:prstGeom>
+          <a:noFill/>
+        </p:spPr>
+        <p:txBody>
+          <a:bodyPr wrap="square">
+            <a:spAutoFit/>
+          </a:bodyPr>
+          <a:lstStyle/>
+          <a:p>
+            <a:pPr>
+              <a:defRPr sz="1700" b="0">
+                <a:solidFill>
+                  <a:srgbClr val="153B50"/>
+                </a:solidFill>
+                <a:latin typeface="Aptos"/>
+              </a:defRPr>
+            </a:pPr>
+            <a:r>
+              <a:t>PCA, LLE, PCA + t-SNE, and PCA + UMAP create different clusters. Both labels appear in several clusters, so cluster count or visual compactness does not measure classification quality.</a:t>
+            </a:r>
+            <a:br/>
+            <a:br/>
+            <a:r>
+              <a:t>PCA + t-SNE has a good AUC on the pictured split, but the three-split average favors PCA + UMAP narrowly. The table lacks patient IDs for patient-level testing.</a:t>
+            </a:r>
+          </a:p>
+        </p:txBody>
+      </p:sp>
+      <p:sp>
+        <p:nvSpPr>
+          <p:cNvPr id="5" name="TextBox 4"/>
+          <p:cNvSpPr txBox="1"/>
+          <p:nvPr/>
+        </p:nvSpPr>
+        <p:spPr>
+          <a:xfrm>
+            <a:off x="594360" y="6473952"/>
+            <a:ext cx="10972800" cy="201168"/>
+          </a:xfrm>
+          <a:prstGeom prst="rect">
+            <a:avLst/>
+          </a:prstGeom>
+          <a:noFill/>
+        </p:spPr>
+        <p:txBody>
+          <a:bodyPr wrap="square">
+            <a:spAutoFit/>
+          </a:bodyPr>
+          <a:lstStyle/>
+          <a:p>
+            <a:pPr>
+              <a:defRPr sz="900" b="0">
+                <a:solidFill>
+                  <a:srgbClr val="5C6770"/>
+                </a:solidFill>
+                <a:latin typeface="Aptos"/>
+              </a:defRPr>
+            </a:pPr>
+            <a:r>
+              <a:t>Notebook extension: setting A, first split shown; AUC beside each map is for that split only.</a:t>
             </a:r>
           </a:p>
         </p:txBody>
@@ -5216,6 +5712,437 @@
 </p:sld>
 </file>
 
+<file path=ppt/slides/slide30.xml><?xml version="1.0" encoding="utf-8"?>
+<p:sld xmlns:a="http://schemas.openxmlformats.org/drawingml/2006/main" xmlns:p="http://schemas.openxmlformats.org/presentationml/2006/main" xmlns:r="http://schemas.openxmlformats.org/officeDocument/2006/relationships">
+  <p:cSld>
+    <p:spTree>
+      <p:nvGrpSpPr>
+        <p:cNvPr id="1" name=""/>
+        <p:cNvGrpSpPr/>
+        <p:nvPr/>
+      </p:nvGrpSpPr>
+      <p:grpSpPr/>
+      <p:sp>
+        <p:nvSpPr>
+          <p:cNvPr id="2" name="TextBox 1"/>
+          <p:cNvSpPr txBox="1"/>
+          <p:nvPr/>
+        </p:nvSpPr>
+        <p:spPr>
+          <a:xfrm>
+            <a:off x="594360" y="320040"/>
+            <a:ext cx="10972800" cy="594360"/>
+          </a:xfrm>
+          <a:prstGeom prst="rect">
+            <a:avLst/>
+          </a:prstGeom>
+          <a:noFill/>
+        </p:spPr>
+        <p:txBody>
+          <a:bodyPr wrap="square">
+            <a:spAutoFit/>
+          </a:bodyPr>
+          <a:lstStyle/>
+          <a:p>
+            <a:pPr>
+              <a:defRPr sz="2800" b="1">
+                <a:solidFill>
+                  <a:srgbClr val="153B50"/>
+                </a:solidFill>
+                <a:latin typeface="Aptos"/>
+              </a:defRPr>
+            </a:pPr>
+            <a:r>
+              <a:t>Eleven-method AUC comparison</a:t>
+            </a:r>
+          </a:p>
+        </p:txBody>
+      </p:sp>
+      <p:pic>
+        <p:nvPicPr>
+          <p:cNvPr id="3" name="Picture 2" descr="eleven_method_auc_comparison.png"/>
+          <p:cNvPicPr>
+            <a:picLocks noChangeAspect="1"/>
+          </p:cNvPicPr>
+          <p:nvPr/>
+        </p:nvPicPr>
+        <p:blipFill>
+          <a:blip r:embed="rId2"/>
+          <a:stretch>
+            <a:fillRect/>
+          </a:stretch>
+        </p:blipFill>
+        <p:spPr>
+          <a:xfrm>
+            <a:off x="594360" y="1024128"/>
+            <a:ext cx="10972800" cy="4739512"/>
+          </a:xfrm>
+          <a:prstGeom prst="rect">
+            <a:avLst/>
+          </a:prstGeom>
+        </p:spPr>
+      </p:pic>
+      <p:sp>
+        <p:nvSpPr>
+          <p:cNvPr id="4" name="TextBox 3"/>
+          <p:cNvSpPr txBox="1"/>
+          <p:nvPr/>
+        </p:nvSpPr>
+        <p:spPr>
+          <a:xfrm>
+            <a:off x="731520" y="5925312"/>
+            <a:ext cx="10789920" cy="411480"/>
+          </a:xfrm>
+          <a:prstGeom prst="rect">
+            <a:avLst/>
+          </a:prstGeom>
+          <a:noFill/>
+        </p:spPr>
+        <p:txBody>
+          <a:bodyPr wrap="square">
+            <a:spAutoFit/>
+          </a:bodyPr>
+          <a:lstStyle/>
+          <a:p>
+            <a:pPr>
+              <a:defRPr sz="1600" b="0">
+                <a:solidFill>
+                  <a:srgbClr val="153B50"/>
+                </a:solidFill>
+                <a:latin typeface="Aptos"/>
+              </a:defRPr>
+            </a:pPr>
+            <a:r>
+              <a:t>Top differences of 0.001–0.002 are too small for a reliable superiority claim; compare CPU cost and uncertainty before choosing a method.</a:t>
+            </a:r>
+          </a:p>
+        </p:txBody>
+      </p:sp>
+      <p:sp>
+        <p:nvSpPr>
+          <p:cNvPr id="5" name="TextBox 4"/>
+          <p:cNvSpPr txBox="1"/>
+          <p:nvPr/>
+        </p:nvSpPr>
+        <p:spPr>
+          <a:xfrm>
+            <a:off x="594360" y="6446520"/>
+            <a:ext cx="10972800" cy="228600"/>
+          </a:xfrm>
+          <a:prstGeom prst="rect">
+            <a:avLst/>
+          </a:prstGeom>
+          <a:noFill/>
+        </p:spPr>
+        <p:txBody>
+          <a:bodyPr wrap="square">
+            <a:spAutoFit/>
+          </a:bodyPr>
+          <a:lstStyle/>
+          <a:p>
+            <a:pPr>
+              <a:defRPr sz="1000" b="0">
+                <a:solidFill>
+                  <a:srgbClr val="5C6770"/>
+                </a:solidFill>
+                <a:latin typeface="Aptos"/>
+              </a:defRPr>
+            </a:pPr>
+            <a:r>
+              <a:t>Source: kaggle/example_outputs/primary_summary.csv; figures generated by the full notebook.</a:t>
+            </a:r>
+          </a:p>
+        </p:txBody>
+      </p:sp>
+    </p:spTree>
+  </p:cSld>
+  <p:clrMapOvr>
+    <a:masterClrMapping/>
+  </p:clrMapOvr>
+</p:sld>
+</file>
+
+<file path=ppt/slides/slide31.xml><?xml version="1.0" encoding="utf-8"?>
+<p:sld xmlns:a="http://schemas.openxmlformats.org/drawingml/2006/main" xmlns:p="http://schemas.openxmlformats.org/presentationml/2006/main" xmlns:r="http://schemas.openxmlformats.org/officeDocument/2006/relationships">
+  <p:cSld>
+    <p:spTree>
+      <p:nvGrpSpPr>
+        <p:cNvPr id="1" name=""/>
+        <p:cNvGrpSpPr/>
+        <p:nvPr/>
+      </p:nvGrpSpPr>
+      <p:grpSpPr/>
+      <p:sp>
+        <p:nvSpPr>
+          <p:cNvPr id="2" name="TextBox 1"/>
+          <p:cNvSpPr txBox="1"/>
+          <p:nvPr/>
+        </p:nvSpPr>
+        <p:spPr>
+          <a:xfrm>
+            <a:off x="594360" y="320040"/>
+            <a:ext cx="10972800" cy="594360"/>
+          </a:xfrm>
+          <a:prstGeom prst="rect">
+            <a:avLst/>
+          </a:prstGeom>
+          <a:noFill/>
+        </p:spPr>
+        <p:txBody>
+          <a:bodyPr wrap="square">
+            <a:spAutoFit/>
+          </a:bodyPr>
+          <a:lstStyle/>
+          <a:p>
+            <a:pPr>
+              <a:defRPr sz="2800" b="1">
+                <a:solidFill>
+                  <a:srgbClr val="153B50"/>
+                </a:solidFill>
+                <a:latin typeface="Aptos"/>
+              </a:defRPr>
+            </a:pPr>
+            <a:r>
+              <a:t>Eleven-method CPU comparison</a:t>
+            </a:r>
+          </a:p>
+        </p:txBody>
+      </p:sp>
+      <p:pic>
+        <p:nvPicPr>
+          <p:cNvPr id="3" name="Picture 2" descr="eleven_method_cpu_comparison.png"/>
+          <p:cNvPicPr>
+            <a:picLocks noChangeAspect="1"/>
+          </p:cNvPicPr>
+          <p:nvPr/>
+        </p:nvPicPr>
+        <p:blipFill>
+          <a:blip r:embed="rId2"/>
+          <a:stretch>
+            <a:fillRect/>
+          </a:stretch>
+        </p:blipFill>
+        <p:spPr>
+          <a:xfrm>
+            <a:off x="594360" y="1024128"/>
+            <a:ext cx="10972800" cy="4702629"/>
+          </a:xfrm>
+          <a:prstGeom prst="rect">
+            <a:avLst/>
+          </a:prstGeom>
+        </p:spPr>
+      </p:pic>
+      <p:sp>
+        <p:nvSpPr>
+          <p:cNvPr id="4" name="TextBox 3"/>
+          <p:cNvSpPr txBox="1"/>
+          <p:nvPr/>
+        </p:nvSpPr>
+        <p:spPr>
+          <a:xfrm>
+            <a:off x="731520" y="5897880"/>
+            <a:ext cx="10789920" cy="502920"/>
+          </a:xfrm>
+          <a:prstGeom prst="rect">
+            <a:avLst/>
+          </a:prstGeom>
+          <a:noFill/>
+        </p:spPr>
+        <p:txBody>
+          <a:bodyPr wrap="square">
+            <a:spAutoFit/>
+          </a:bodyPr>
+          <a:lstStyle/>
+          <a:p>
+            <a:pPr>
+              <a:defRPr sz="1600" b="0">
+                <a:solidFill>
+                  <a:srgbClr val="153B50"/>
+                </a:solidFill>
+                <a:latin typeface="Aptos"/>
+              </a:defRPr>
+            </a:pPr>
+            <a:r>
+              <a:t>PCA + UMAP uses about 1.74s on HAM and 1.72s on blood cells. The nearest AUC leaders use about 0.12s (Isomap) and 0.02s (PCA). Times depend on hardware and sample size.</a:t>
+            </a:r>
+          </a:p>
+        </p:txBody>
+      </p:sp>
+      <p:sp>
+        <p:nvSpPr>
+          <p:cNvPr id="5" name="TextBox 4"/>
+          <p:cNvSpPr txBox="1"/>
+          <p:nvPr/>
+        </p:nvSpPr>
+        <p:spPr>
+          <a:xfrm>
+            <a:off x="594360" y="6446520"/>
+            <a:ext cx="10972800" cy="228600"/>
+          </a:xfrm>
+          <a:prstGeom prst="rect">
+            <a:avLst/>
+          </a:prstGeom>
+          <a:noFill/>
+        </p:spPr>
+        <p:txBody>
+          <a:bodyPr wrap="square">
+            <a:spAutoFit/>
+          </a:bodyPr>
+          <a:lstStyle/>
+          <a:p>
+            <a:pPr>
+              <a:defRPr sz="1000" b="0">
+                <a:solidFill>
+                  <a:srgbClr val="5C6770"/>
+                </a:solidFill>
+                <a:latin typeface="Aptos"/>
+              </a:defRPr>
+            </a:pPr>
+            <a:r>
+              <a:t>Process CPU time excludes UMAP compilation warmup; logarithmic horizontal axis.</a:t>
+            </a:r>
+          </a:p>
+        </p:txBody>
+      </p:sp>
+    </p:spTree>
+  </p:cSld>
+  <p:clrMapOvr>
+    <a:masterClrMapping/>
+  </p:clrMapOvr>
+</p:sld>
+</file>
+
+<file path=ppt/slides/slide32.xml><?xml version="1.0" encoding="utf-8"?>
+<p:sld xmlns:a="http://schemas.openxmlformats.org/drawingml/2006/main" xmlns:p="http://schemas.openxmlformats.org/presentationml/2006/main" xmlns:r="http://schemas.openxmlformats.org/officeDocument/2006/relationships">
+  <p:cSld>
+    <p:spTree>
+      <p:nvGrpSpPr>
+        <p:cNvPr id="1" name=""/>
+        <p:cNvGrpSpPr/>
+        <p:nvPr/>
+      </p:nvGrpSpPr>
+      <p:grpSpPr/>
+      <p:sp>
+        <p:nvSpPr>
+          <p:cNvPr id="2" name="TextBox 1"/>
+          <p:cNvSpPr txBox="1"/>
+          <p:nvPr/>
+        </p:nvSpPr>
+        <p:spPr>
+          <a:xfrm>
+            <a:off x="502920" y="228600"/>
+            <a:ext cx="10972800" cy="640080"/>
+          </a:xfrm>
+          <a:prstGeom prst="rect">
+            <a:avLst/>
+          </a:prstGeom>
+          <a:noFill/>
+        </p:spPr>
+        <p:txBody>
+          <a:bodyPr wrap="square">
+            <a:spAutoFit/>
+          </a:bodyPr>
+          <a:lstStyle/>
+          <a:p>
+            <a:pPr>
+              <a:defRPr sz="2900" b="1">
+                <a:solidFill>
+                  <a:srgbClr val="153B50"/>
+                </a:solidFill>
+                <a:latin typeface="Aptos"/>
+              </a:defRPr>
+            </a:pPr>
+            <a:r>
+              <a:t>Interpretation and next steps</a:t>
+            </a:r>
+          </a:p>
+        </p:txBody>
+      </p:sp>
+      <p:sp>
+        <p:nvSpPr>
+          <p:cNvPr id="3" name="TextBox 2"/>
+          <p:cNvSpPr txBox="1"/>
+          <p:nvPr/>
+        </p:nvSpPr>
+        <p:spPr>
+          <a:xfrm>
+            <a:off x="731520" y="1234440"/>
+            <a:ext cx="10789920" cy="4846320"/>
+          </a:xfrm>
+          <a:prstGeom prst="rect">
+            <a:avLst/>
+          </a:prstGeom>
+          <a:noFill/>
+        </p:spPr>
+        <p:txBody>
+          <a:bodyPr wrap="square">
+            <a:spAutoFit/>
+          </a:bodyPr>
+          <a:lstStyle/>
+          <a:p>
+            <a:pPr>
+              <a:defRPr sz="2100" b="0">
+                <a:solidFill>
+                  <a:srgbClr val="153B50"/>
+                </a:solidFill>
+                <a:latin typeface="Aptos"/>
+              </a:defRPr>
+            </a:pPr>
+            <a:r>
+              <a:t>Performance changes with split and parameter choice. The 8 × 8 lesion images limit clinical meaning. The blood-cell table lacks patient-level validation.</a:t>
+            </a:r>
+            <a:br/>
+            <a:br/>
+            <a:r>
+              <a:t>For a journal study: use original or validated features, external cohorts, nested tuning, uncertainty intervals, and lesion locations if FROC is required.</a:t>
+            </a:r>
+          </a:p>
+        </p:txBody>
+      </p:sp>
+      <p:sp>
+        <p:nvSpPr>
+          <p:cNvPr id="4" name="TextBox 3"/>
+          <p:cNvSpPr txBox="1"/>
+          <p:nvPr/>
+        </p:nvSpPr>
+        <p:spPr>
+          <a:xfrm>
+            <a:off x="594360" y="6446520"/>
+            <a:ext cx="10972800" cy="274320"/>
+          </a:xfrm>
+          <a:prstGeom prst="rect">
+            <a:avLst/>
+          </a:prstGeom>
+          <a:noFill/>
+        </p:spPr>
+        <p:txBody>
+          <a:bodyPr wrap="square">
+            <a:spAutoFit/>
+          </a:bodyPr>
+          <a:lstStyle/>
+          <a:p>
+            <a:pPr>
+              <a:defRPr sz="1000" b="0">
+                <a:solidFill>
+                  <a:srgbClr val="5C6770"/>
+                </a:solidFill>
+                <a:latin typeface="Aptos"/>
+              </a:defRPr>
+            </a:pPr>
+            <a:r>
+              <a:t>Sources and exact numbers: AML_research_report.docx and results/primary_summary.csv</a:t>
+            </a:r>
+          </a:p>
+        </p:txBody>
+      </p:sp>
+    </p:spTree>
+  </p:cSld>
+  <p:clrMapOvr>
+    <a:masterClrMapping/>
+  </p:clrMapOvr>
+</p:sld>
+</file>
+
 <file path=ppt/slides/slide4.xml><?xml version="1.0" encoding="utf-8"?>
 <p:sld xmlns:a="http://schemas.openxmlformats.org/drawingml/2006/main" xmlns:p="http://schemas.openxmlformats.org/presentationml/2006/main" xmlns:r="http://schemas.openxmlformats.org/officeDocument/2006/relationships">
   <p:cSld>
@@ -5457,7 +6384,7 @@
               </a:defRPr>
             </a:pPr>
             <a:r>
-              <a:t>Global geometry: PCA, kernel PCA, MDS, PCoA</a:t>
+              <a:t>The prediction model used in every run</a:t>
             </a:r>
           </a:p>
         </p:txBody>
@@ -5493,17 +6420,22 @@
               </a:defRPr>
             </a:pPr>
             <a:r>
-              <a:t>PCA keeps directions with the most variance. It is fast, but large variance need not represent disease.</a:t>
-            </a:r>
-            <a:br/>
-            <a:br/>
-            <a:r>
-              <a:t>Kernel PCA uses an RBF similarity so curved patterns can become separable. Its gamma setting determines the scale of similarity.</a:t>
-            </a:r>
-            <a:br/>
-            <a:br/>
-            <a:r>
-              <a:t>MDS tries to preserve Euclidean distances between every pair. PCoA eigendecomposes a centered distance matrix; here cosine distance is primary. Both can devote two dimensions to variation unrelated to the label.</a:t>
+              <a:t>1  Split records: HAM10000 by lesion ID; blood cells by stratified rows. Each seed uses 750 training and 300 held-out records.</a:t>
+            </a:r>
+            <a:br/>
+            <a:br/>
+            <a:r>
+              <a:t>2  Fit StandardScaler on training features only. Fit an unsupervised 2D embedding on those standardized records; map held-out records into the same coordinates.</a:t>
+            </a:r>
+            <a:br/>
+            <a:br/>
+            <a:r>
+              <a:t>3  Fit LogisticRegression(class_weight='balanced', max_iter=1000, random_state=100+seed) on the training coordinates. predict_proba gives the positive-class score; a fixed 0.5 cutoff gives class predictions.</a:t>
+            </a:r>
+            <a:br/>
+            <a:br/>
+            <a:r>
+              <a:t>The embedding is a feature extractor. Logistic regression is the classifier; its settings are identical across methods.</a:t>
             </a:r>
           </a:p>
         </p:txBody>
@@ -5557,7 +6489,7 @@
               </a:defRPr>
             </a:pPr>
             <a:r>
-              <a:t>Local geometry: SNE, t-SNE, hybrid, UMAP, Isomap</a:t>
+              <a:t>What the fixed classifier lets us compare</a:t>
             </a:r>
           </a:p>
         </p:txBody>
@@ -5593,17 +6525,17 @@
               </a:defRPr>
             </a:pPr>
             <a:r>
-              <a:t>SNE and t-SNE match neighbor probabilities. t-SNE's heavy tail reduces crowding; perplexity controls neighborhood scale. PCA plus t-SNE first filters the inputs to at most 30 components.</a:t>
-            </a:r>
-            <a:br/>
-            <a:br/>
-            <a:r>
-              <a:t>UMAP builds a fuzzy neighbor graph; its neighbor count controls how local the map is. Isomap uses graph shortest paths to estimate geodesic distances.</a:t>
-            </a:r>
-            <a:br/>
-            <a:br/>
-            <a:r>
-              <a:t>These maps can reveal local structure, but they may distort global distances and change when the neighborhood parameter changes.</a:t>
+              <a:t>The same linear decision rule in two coordinates makes changes in held-out ROC AUC, log loss, and confusion counts reflect the complete representation pipeline. Class weighting increases the influence of the minority class during fitting.</a:t>
+            </a:r>
+            <a:br/>
+            <a:br/>
+            <a:r>
+              <a:t>A high AUC means better ranking across thresholds; it does not imply a useful 0.5 cutoff or calibrated probabilities. Accuracy may favor the majority class. Read sensitivity and precision together when positives are rare.</a:t>
+            </a:r>
+            <a:br/>
+            <a:br/>
+            <a:r>
+              <a:t>SNE, t-SNE, and MDS use a five-neighbor weighted approximation for unseen points. Their scores include the quality of that approximation. These are small pilot samples, not validated diagnostic models.</a:t>
             </a:r>
           </a:p>
         </p:txBody>
@@ -5657,7 +6589,7 @@
               </a:defRPr>
             </a:pPr>
             <a:r>
-              <a:t>How unseen test records enter each map</a:t>
+              <a:t>Global geometry: PCA, kernel PCA, MDS, PCoA</a:t>
             </a:r>
           </a:p>
         </p:txBody>
@@ -5693,17 +6625,17 @@
               </a:defRPr>
             </a:pPr>
             <a:r>
-              <a:t>PCA, kernel PCA, UMAP, and Isomap transform new records directly. PCoA uses a distance-based Gower extension.</a:t>
-            </a:r>
-            <a:br/>
-            <a:br/>
-            <a:r>
-              <a:t>The chosen SNE, t-SNE, and MDS implementations have no native test transform. A five-neighbor weighted regressor estimates test coordinates from their training maps.</a:t>
-            </a:r>
-            <a:br/>
-            <a:br/>
-            <a:r>
-              <a:t>The measured ranking therefore compares complete representation pipelines, including this approximation. It does not compare only the training maps.</a:t>
+              <a:t>PCA keeps directions with the most variance. It is fast, but large variance need not represent disease.</a:t>
+            </a:r>
+            <a:br/>
+            <a:br/>
+            <a:r>
+              <a:t>Kernel PCA uses an RBF similarity so curved patterns can become separable. Its gamma setting determines the scale of similarity.</a:t>
+            </a:r>
+            <a:br/>
+            <a:br/>
+            <a:r>
+              <a:t>MDS tries to preserve Euclidean distances between every pair. PCoA eigendecomposes a centered distance matrix; here cosine distance is primary. Both can devote two dimensions to variation unrelated to the label.</a:t>
             </a:r>
           </a:p>
         </p:txBody>
@@ -5757,7 +6689,7 @@
               </a:defRPr>
             </a:pPr>
             <a:r>
-              <a:t>Method readings: PCA through the hybrid</a:t>
+              <a:t>Local geometry: SNE, t-SNE, hybrid, UMAP, Isomap</a:t>
             </a:r>
           </a:p>
         </p:txBody>
@@ -5793,27 +6725,17 @@
               </a:defRPr>
             </a:pPr>
             <a:r>
-              <a:t>PCA: blood-cell AUC 0.630, the best there. A simple linear map may suffice for these selected features; it is weakest on HAM AUC at 0.602.</a:t>
-            </a:r>
-            <a:br/>
-            <a:br/>
-            <a:r>
-              <a:t>Kernel PCA: 0.638 HAM, 0.624 blood. Curved RBF similarities help modestly, with kernel scale affecting the map.</a:t>
-            </a:r>
-            <a:br/>
-            <a:br/>
-            <a:r>
-              <a:t>SNE: 0.616 HAM, 0.581 blood. Local-neighbor matching does not consistently retain the label signal.</a:t>
-            </a:r>
-            <a:br/>
-            <a:br/>
-            <a:r>
-              <a:t>t-SNE: 0.638 HAM, 0.622 blood. Better than SNE on both, but its approximate test transform limits interpretation.</a:t>
-            </a:r>
-            <a:br/>
-            <a:br/>
-            <a:r>
-              <a:t>PCA plus t-SNE: 0.632 HAM, 0.616 blood. The preprocessing step shows no gain over t-SNE in this pilot.</a:t>
+              <a:t>SNE and t-SNE match neighbor probabilities. t-SNE's heavy tail reduces crowding; perplexity controls neighborhood scale. PCA plus t-SNE first filters the inputs to at most 30 components.</a:t>
+            </a:r>
+            <a:br/>
+            <a:br/>
+            <a:r>
+              <a:t>UMAP builds a fuzzy neighbor graph; its neighbor count controls how local the map is. Isomap uses graph shortest paths to estimate geodesic distances.</a:t>
+            </a:r>
+            <a:br/>
+            <a:br/>
+            <a:r>
+              <a:t>These maps can reveal local structure, but they may distort global distances and change when the neighborhood parameter changes.</a:t>
             </a:r>
           </a:p>
         </p:txBody>

</xml_diff>